<commit_message>
docs(agente): completar informe y presentación (justificación, conclusiones, declaración de IA, integrantes)
Co-Authored-By: Claude Sonnet 5.5 <noreply@anthropic.com>
</commit_message>
<xml_diff>
--- a/docs/agente/Presentacion_EP2_Agente_TodoBarato.pptx
+++ b/docs/agente/Presentacion_EP2_Agente_TodoBarato.pptx
@@ -115,30 +115,30 @@
   <p:extLst>
     <p:ext uri="{521415D9-36F7-43E2-AB2F-B90AF26B5E84}">
       <p14:sectionLst xmlns:p14="http://schemas.microsoft.com/office/powerpoint/2010/main">
-        <p14:section name="Apertura" id="{e6d099cd-2381-faa2-ca07-877a66cd5271}">
+        <p14:section name="Apertura" id="{e612a812-f61a-55ab-3425-0018cc0bdf9a}">
           <p14:sldIdLst>
             <p14:sldId id="256"/>
           </p14:sldIdLst>
         </p14:section>
-        <p14:section name="Diseño" id="{cc93d2ed-b46d-7870-da2a-2d3c7c0af9b0}">
+        <p14:section name="Diseño" id="{26533e28-57f0-1d1c-94f2-69b15cb39ab0}">
           <p14:sldIdLst>
             <p14:sldId id="257"/>
             <p14:sldId id="258"/>
             <p14:sldId id="259"/>
           </p14:sldIdLst>
         </p14:section>
-        <p14:section name="Comportamiento" id="{696621e2-153d-6846-9e78-63702e72ed3b}">
+        <p14:section name="Comportamiento" id="{c8f46d86-7439-02c5-f4bf-9872f6cccd7f}">
           <p14:sldIdLst>
             <p14:sldId id="260"/>
             <p14:sldId id="261"/>
           </p14:sldIdLst>
         </p14:section>
-        <p14:section name="Demostración" id="{be84526e-488b-5277-acc7-c3d87e81c6c0}">
+        <p14:section name="Demostración" id="{551f30eb-38d2-7e4c-4856-7e84ab021532}">
           <p14:sldIdLst>
             <p14:sldId id="262"/>
           </p14:sldIdLst>
         </p14:section>
-        <p14:section name="Cierre" id="{aecb5c02-e4e5-a9c2-b2fe-3bb90acf9c86}">
+        <p14:section name="Cierre" id="{65a547e5-cd4d-e06d-4b93-caf9f1f126c3}">
           <p14:sldIdLst>
             <p14:sldId id="263"/>
             <p14:sldId id="264"/>
@@ -548,7 +548,7 @@
           <a:p>
             <a:r>
               <a:rPr lang="en-US" dirty="0"/>
-              <a:t>Presenta: [Integrante 1]. 20 s. Qué problema resuelve y qué verán: arquitectura, planificación, memoria y demo en vivo.</a:t>
+              <a:t>Presenta: Nicolas. 20 s. Qué problema resuelve y qué verán: arquitectura, planificación, memoria y demo en vivo.</a:t>
             </a:r>
             <a:endParaRPr lang="en-US" dirty="0"/>
           </a:p>
@@ -636,7 +636,7 @@
           <a:p>
             <a:r>
               <a:rPr lang="en-US" dirty="0"/>
-              <a:t>Presenta: [Integrante 1]. 60 s. Caso: asesor de compras de un comparador de precios. El agente deja registro en la base: alertas y listas.</a:t>
+              <a:t>Presenta: Nicolas. 60 s. Caso: asesor de compras de un comparador de precios. El agente deja registro en la base: alertas y listas.</a:t>
             </a:r>
             <a:endParaRPr lang="en-US" dirty="0"/>
           </a:p>
@@ -724,7 +724,7 @@
           <a:p>
             <a:r>
               <a:rPr lang="en-US" dirty="0"/>
-              <a:t>Presenta: [Integrante 1]. 60 s. Recorrer de izquierda a derecha: API → AgentService → grafo LangGraph. A la derecha: Gemini, checkpointer (memoria de corto plazo), 11 herramientas y memoria de largo plazo con embeddings.</a:t>
+              <a:t>Presenta: Nicolas. 60 s. Recorrer de izquierda a derecha: API → AgentService → grafo LangGraph. A la derecha: Gemini, checkpointer (memoria de corto plazo), 11 herramientas y memoria de largo plazo con embeddings.</a:t>
             </a:r>
             <a:endParaRPr lang="en-US" dirty="0"/>
           </a:p>
@@ -812,7 +812,7 @@
           <a:p>
             <a:r>
               <a:rPr lang="en-US" dirty="0"/>
-              <a:t>Presenta: [Integrante 2]. 60 s. Nodos: recall → plan → act ⇄ tools → reflect. El ciclo rojo es la replanificación (máx. 2). give_up cierra las llamadas pendientes si se pasa de 10 pasos.</a:t>
+              <a:t>Presenta: Ariel. 60 s. Nodos: recall → plan → act ⇄ tools → reflect. El ciclo rojo es la replanificación (máx. 2). give_up cierra las llamadas pendientes si se pasa de 10 pasos.</a:t>
             </a:r>
             <a:endParaRPr lang="en-US" dirty="0"/>
           </a:p>
@@ -900,7 +900,7 @@
           <a:p>
             <a:r>
               <a:rPr lang="en-US" dirty="0"/>
-              <a:t>Presenta: [Integrante 2]. 60 s. Las reglas de diagnóstico son código determinista (se prueban sin LLM). Frenos anti-bucle: máx. 2 replanificaciones y cada motivo replanifica una sola vez.</a:t>
+              <a:t>Presenta: Ariel. 60 s. Las reglas de diagnóstico son código determinista (se prueban sin LLM). Frenos anti-bucle: máx. 2 replanificaciones y cada motivo replanifica una sola vez.</a:t>
             </a:r>
             <a:endParaRPr lang="en-US" dirty="0"/>
           </a:p>
@@ -988,7 +988,7 @@
           <a:p>
             <a:r>
               <a:rPr lang="en-US" dirty="0"/>
-              <a:t>Presenta: [Integrante 1]. 60 s. Corto plazo = checkpointer del hilo (sobrevive a reinicios; Postgres con varias réplicas). Largo plazo = tabla agent_memories con embeddings. El caso clave: «Recomiéndame un celular» no comparte palabras con «Prefiero Samsung»: por eso existe la memoria núcleo.</a:t>
+              <a:t>Presenta: Nicolas. 60 s. Corto plazo = checkpointer del hilo (sobrevive a reinicios; Postgres con varias réplicas). Largo plazo = tabla agent_memories con embeddings. El caso clave: «Recomiéndame un celular» no comparte palabras con «Prefiero Samsung»: por eso existe la memoria núcleo.</a:t>
             </a:r>
             <a:endParaRPr lang="en-US" dirty="0"/>
           </a:p>
@@ -1164,7 +1164,7 @@
           <a:p>
             <a:r>
               <a:rPr lang="en-US" dirty="0"/>
-              <a:t>Presenta: [Integrante 2]. 45 s. Cifras reales del repositorio. La demo con Gemini completó las historias 1 a 3; la cuota gratuita se agotó en la 4 y el agente lo informó sin caerse. Pruebas en vivo con Gemini y contra Postgres real: pasaron.</a:t>
+              <a:t>Presenta: Ariel. 45 s. Cifras reales del repositorio. La demo con Gemini completó las historias 1 a 3; la cuota gratuita se agotó en la 4 y el agente lo informó sin caerse. Pruebas en vivo con Gemini y contra Postgres real: pasaron.</a:t>
             </a:r>
             <a:endParaRPr lang="en-US" dirty="0"/>
           </a:p>
@@ -1252,7 +1252,7 @@
           <a:p>
             <a:r>
               <a:rPr lang="en-US" dirty="0"/>
-              <a:t>A completar por el equipo: justificación técnica con sus propias palabras (la pauta no permite redactarla con IA). Presentan ambos. Preparar respuestas para la ronda de preguntas (10 min).</a:t>
+              <a:t>Presentan ambos. 60 s. Cada fila: decisión y razón medida. Preparar la ronda de preguntas (10 min): por qué LangGraph y no el orquestador propio, por qué reglas deterministas, qué falló con los embeddings locales, qué no se probó (pooler real de Supabase).</a:t>
             </a:r>
             <a:endParaRPr lang="en-US" dirty="0"/>
           </a:p>
@@ -2001,7 +2001,7 @@
                 <a:ea typeface="Calibri" pitchFamily="34" charset="-122"/>
                 <a:cs typeface="Calibri" pitchFamily="34" charset="-120"/>
               </a:rPr>
-              <a:t>[Integrante 1] · [Integrante 2]</a:t>
+              <a:t>Nicolas Estefania · Ariel Espinoza</a:t>
             </a:r>
             <a:endParaRPr lang="en-US" sz="1400" dirty="0"/>
           </a:p>
@@ -6563,8 +6563,8 @@
         </p:nvSpPr>
         <p:spPr>
           <a:xfrm>
-            <a:off x="548640" y="2743200"/>
-            <a:ext cx="8046720" cy="365760"/>
+            <a:off x="548640" y="2514600"/>
+            <a:ext cx="2377440" cy="502920"/>
           </a:xfrm>
           <a:prstGeom prst="rect">
             <a:avLst/>
@@ -6580,7 +6580,7 @@
               <a:buNone/>
             </a:pPr>
             <a:r>
-              <a:rPr lang="en-US" sz="1800" b="1" dirty="0">
+              <a:rPr lang="en-US" sz="1600" b="1" dirty="0">
                 <a:solidFill>
                   <a:schemeClr val="accent2"/>
                 </a:solidFill>
@@ -6588,9 +6588,9 @@
                 <a:ea typeface="Calibri" pitchFamily="34" charset="-122"/>
                 <a:cs typeface="Calibri" pitchFamily="34" charset="-120"/>
               </a:rPr>
-              <a:t>A completar por el equipo, con sus propias palabras</a:t>
-            </a:r>
-            <a:endParaRPr lang="en-US" sz="1800" dirty="0"/>
+              <a:t>LangGraph</a:t>
+            </a:r>
+            <a:endParaRPr lang="en-US" sz="1600" dirty="0"/>
           </a:p>
         </p:txBody>
       </p:sp>
@@ -6602,8 +6602,8 @@
         </p:nvSpPr>
         <p:spPr>
           <a:xfrm>
-            <a:off x="548640" y="3154680"/>
-            <a:ext cx="8046720" cy="1463040"/>
+            <a:off x="3017520" y="2514600"/>
+            <a:ext cx="5577840" cy="502920"/>
           </a:xfrm>
           <a:prstGeom prst="rect">
             <a:avLst/>
@@ -6612,79 +6612,258 @@
           <a:ln/>
         </p:spPr>
         <p:txBody>
-          <a:bodyPr wrap="square" lIns="0" tIns="0" rIns="0" bIns="0" rtlCol="0" anchor="t"/>
-          <a:lstStyle/>
-          <a:p>
-            <a:pPr marL="342900" indent="-342900">
-              <a:spcAft>
-                <a:spcPts val="400"/>
-              </a:spcAft>
-              <a:buSzPct val="100000"/>
-              <a:buChar char="•"/>
-            </a:pPr>
-            <a:r>
-              <a:rPr lang="en-US" sz="1600" dirty="0">
+          <a:bodyPr wrap="square" lIns="0" tIns="0" rIns="0" bIns="0" rtlCol="0" anchor="ctr"/>
+          <a:lstStyle/>
+          <a:p>
+            <a:pPr indent="0" marL="0">
+              <a:buNone/>
+            </a:pPr>
+            <a:r>
+              <a:rPr lang="en-US" sz="1400" dirty="0">
                 <a:solidFill>
                   <a:schemeClr val="bg1"/>
                 </a:solidFill>
-              </a:rPr>
-              <a:t>LangGraph y el ciclo reflect → plan</a:t>
+                <a:latin typeface="Calibri" pitchFamily="34" charset="0"/>
+                <a:ea typeface="Calibri" pitchFamily="34" charset="-122"/>
+                <a:cs typeface="Calibri" pitchFamily="34" charset="-120"/>
+              </a:rPr>
+              <a:t>el flujo tiene ciclo (reflect → plan), estado y checkpointer; el orquestador previo no guardaba estado</a:t>
+            </a:r>
+            <a:endParaRPr lang="en-US" sz="1400" dirty="0"/>
+          </a:p>
+        </p:txBody>
+      </p:sp>
+      <p:sp>
+        <p:nvSpPr>
+          <p:cNvPr id="6" name="Text 3"/>
+          <p:cNvSpPr txBox="1"/>
+          <p:nvPr/>
+        </p:nvSpPr>
+        <p:spPr>
+          <a:xfrm>
+            <a:off x="548640" y="3081528"/>
+            <a:ext cx="2377440" cy="502920"/>
+          </a:xfrm>
+          <a:prstGeom prst="rect">
+            <a:avLst/>
+          </a:prstGeom>
+          <a:noFill/>
+          <a:ln/>
+        </p:spPr>
+        <p:txBody>
+          <a:bodyPr wrap="square" lIns="0" tIns="0" rIns="0" bIns="0" rtlCol="0" anchor="ctr"/>
+          <a:lstStyle/>
+          <a:p>
+            <a:pPr indent="0" marL="0">
+              <a:buNone/>
+            </a:pPr>
+            <a:r>
+              <a:rPr lang="en-US" sz="1600" b="1" dirty="0">
+                <a:solidFill>
+                  <a:schemeClr val="accent2"/>
+                </a:solidFill>
+                <a:latin typeface="Calibri" pitchFamily="34" charset="0"/>
+                <a:ea typeface="Calibri" pitchFamily="34" charset="-122"/>
+                <a:cs typeface="Calibri" pitchFamily="34" charset="-120"/>
+              </a:rPr>
+              <a:t>Reglas en código</a:t>
             </a:r>
             <a:endParaRPr lang="en-US" sz="1600" dirty="0"/>
           </a:p>
-          <a:p>
-            <a:pPr marL="342900" indent="-342900">
-              <a:spcAft>
-                <a:spcPts val="400"/>
-              </a:spcAft>
-              <a:buSzPct val="100000"/>
-              <a:buChar char="•"/>
-            </a:pPr>
-            <a:r>
-              <a:rPr lang="en-US" sz="1600" dirty="0">
+        </p:txBody>
+      </p:sp>
+      <p:sp>
+        <p:nvSpPr>
+          <p:cNvPr id="7" name="Text 4"/>
+          <p:cNvSpPr txBox="1"/>
+          <p:nvPr/>
+        </p:nvSpPr>
+        <p:spPr>
+          <a:xfrm>
+            <a:off x="3017520" y="3081528"/>
+            <a:ext cx="5577840" cy="502920"/>
+          </a:xfrm>
+          <a:prstGeom prst="rect">
+            <a:avLst/>
+          </a:prstGeom>
+          <a:noFill/>
+          <a:ln/>
+        </p:spPr>
+        <p:txBody>
+          <a:bodyPr wrap="square" lIns="0" tIns="0" rIns="0" bIns="0" rtlCol="0" anchor="ctr"/>
+          <a:lstStyle/>
+          <a:p>
+            <a:pPr indent="0" marL="0">
+              <a:buNone/>
+            </a:pPr>
+            <a:r>
+              <a:rPr lang="en-US" sz="1400" dirty="0">
                 <a:solidFill>
                   <a:schemeClr val="bg1"/>
                 </a:solidFill>
-              </a:rPr>
-              <a:t>Reglas deterministas frente al LLM</a:t>
+                <a:latin typeface="Calibri" pitchFamily="34" charset="0"/>
+                <a:ea typeface="Calibri" pitchFamily="34" charset="-122"/>
+                <a:cs typeface="Calibri" pitchFamily="34" charset="-120"/>
+              </a:rPr>
+              <a:t>diagnóstico, tendencia y presupuesto se prueban sin red: 88 pruebas</a:t>
+            </a:r>
+            <a:endParaRPr lang="en-US" sz="1400" dirty="0"/>
+          </a:p>
+        </p:txBody>
+      </p:sp>
+      <p:sp>
+        <p:nvSpPr>
+          <p:cNvPr id="8" name="Text 5"/>
+          <p:cNvSpPr txBox="1"/>
+          <p:nvPr/>
+        </p:nvSpPr>
+        <p:spPr>
+          <a:xfrm>
+            <a:off x="548640" y="3648456"/>
+            <a:ext cx="2377440" cy="502920"/>
+          </a:xfrm>
+          <a:prstGeom prst="rect">
+            <a:avLst/>
+          </a:prstGeom>
+          <a:noFill/>
+          <a:ln/>
+        </p:spPr>
+        <p:txBody>
+          <a:bodyPr wrap="square" lIns="0" tIns="0" rIns="0" bIns="0" rtlCol="0" anchor="ctr"/>
+          <a:lstStyle/>
+          <a:p>
+            <a:pPr indent="0" marL="0">
+              <a:buNone/>
+            </a:pPr>
+            <a:r>
+              <a:rPr lang="en-US" sz="1600" b="1" dirty="0">
+                <a:solidFill>
+                  <a:schemeClr val="accent2"/>
+                </a:solidFill>
+                <a:latin typeface="Calibri" pitchFamily="34" charset="0"/>
+                <a:ea typeface="Calibri" pitchFamily="34" charset="-122"/>
+                <a:cs typeface="Calibri" pitchFamily="34" charset="-120"/>
+              </a:rPr>
+              <a:t>Memoria núcleo</a:t>
             </a:r>
             <a:endParaRPr lang="en-US" sz="1600" dirty="0"/>
           </a:p>
-          <a:p>
-            <a:pPr marL="342900" indent="-342900">
-              <a:spcAft>
-                <a:spcPts val="400"/>
-              </a:spcAft>
-              <a:buSzPct val="100000"/>
-              <a:buChar char="•"/>
-            </a:pPr>
-            <a:r>
-              <a:rPr lang="en-US" sz="1600" dirty="0">
+        </p:txBody>
+      </p:sp>
+      <p:sp>
+        <p:nvSpPr>
+          <p:cNvPr id="9" name="Text 6"/>
+          <p:cNvSpPr txBox="1"/>
+          <p:nvPr/>
+        </p:nvSpPr>
+        <p:spPr>
+          <a:xfrm>
+            <a:off x="3017520" y="3648456"/>
+            <a:ext cx="5577840" cy="502920"/>
+          </a:xfrm>
+          <a:prstGeom prst="rect">
+            <a:avLst/>
+          </a:prstGeom>
+          <a:noFill/>
+          <a:ln/>
+        </p:spPr>
+        <p:txBody>
+          <a:bodyPr wrap="square" lIns="0" tIns="0" rIns="0" bIns="0" rtlCol="0" anchor="ctr"/>
+          <a:lstStyle/>
+          <a:p>
+            <a:pPr indent="0" marL="0">
+              <a:buNone/>
+            </a:pPr>
+            <a:r>
+              <a:rPr lang="en-US" sz="1400" dirty="0">
                 <a:solidFill>
                   <a:schemeClr val="bg1"/>
                 </a:solidFill>
-              </a:rPr>
-              <a:t>Checkpointer Postgres y embeddings semánticos</a:t>
+                <a:latin typeface="Calibri" pitchFamily="34" charset="0"/>
+                <a:ea typeface="Calibri" pitchFamily="34" charset="-122"/>
+                <a:cs typeface="Calibri" pitchFamily="34" charset="-120"/>
+              </a:rPr>
+              <a:t>con embeddings locales «Recomiéndame un celular» no recuperaba «Prefiero Samsung»</a:t>
+            </a:r>
+            <a:endParaRPr lang="en-US" sz="1400" dirty="0"/>
+          </a:p>
+        </p:txBody>
+      </p:sp>
+      <p:sp>
+        <p:nvSpPr>
+          <p:cNvPr id="10" name="Text 7"/>
+          <p:cNvSpPr txBox="1"/>
+          <p:nvPr/>
+        </p:nvSpPr>
+        <p:spPr>
+          <a:xfrm>
+            <a:off x="548640" y="4215384"/>
+            <a:ext cx="2377440" cy="502920"/>
+          </a:xfrm>
+          <a:prstGeom prst="rect">
+            <a:avLst/>
+          </a:prstGeom>
+          <a:noFill/>
+          <a:ln/>
+        </p:spPr>
+        <p:txBody>
+          <a:bodyPr wrap="square" lIns="0" tIns="0" rIns="0" bIns="0" rtlCol="0" anchor="ctr"/>
+          <a:lstStyle/>
+          <a:p>
+            <a:pPr indent="0" marL="0">
+              <a:buNone/>
+            </a:pPr>
+            <a:r>
+              <a:rPr lang="en-US" sz="1600" b="1" dirty="0">
+                <a:solidFill>
+                  <a:schemeClr val="accent2"/>
+                </a:solidFill>
+                <a:latin typeface="Calibri" pitchFamily="34" charset="0"/>
+                <a:ea typeface="Calibri" pitchFamily="34" charset="-122"/>
+                <a:cs typeface="Calibri" pitchFamily="34" charset="-120"/>
+              </a:rPr>
+              <a:t>Checkpointer Postgres</a:t>
             </a:r>
             <a:endParaRPr lang="en-US" sz="1600" dirty="0"/>
           </a:p>
-          <a:p>
-            <a:pPr marL="342900" indent="-342900">
-              <a:spcAft>
-                <a:spcPts val="400"/>
-              </a:spcAft>
-              <a:buSzPct val="100000"/>
-              <a:buChar char="•"/>
-            </a:pPr>
-            <a:r>
-              <a:rPr lang="en-US" sz="1600" dirty="0">
+        </p:txBody>
+      </p:sp>
+      <p:sp>
+        <p:nvSpPr>
+          <p:cNvPr id="11" name="Text 8"/>
+          <p:cNvSpPr txBox="1"/>
+          <p:nvPr/>
+        </p:nvSpPr>
+        <p:spPr>
+          <a:xfrm>
+            <a:off x="3017520" y="4215384"/>
+            <a:ext cx="5577840" cy="502920"/>
+          </a:xfrm>
+          <a:prstGeom prst="rect">
+            <a:avLst/>
+          </a:prstGeom>
+          <a:noFill/>
+          <a:ln/>
+        </p:spPr>
+        <p:txBody>
+          <a:bodyPr wrap="square" lIns="0" tIns="0" rIns="0" bIns="0" rtlCol="0" anchor="ctr"/>
+          <a:lstStyle/>
+          <a:p>
+            <a:pPr indent="0" marL="0">
+              <a:buNone/>
+            </a:pPr>
+            <a:r>
+              <a:rPr lang="en-US" sz="1400" dirty="0">
                 <a:solidFill>
                   <a:schemeClr val="bg1"/>
                 </a:solidFill>
-              </a:rPr>
-              <a:t>Límites conocidos y siguientes pasos</a:t>
-            </a:r>
-            <a:endParaRPr lang="en-US" sz="1600" dirty="0"/>
+                <a:latin typeface="Calibri" pitchFamily="34" charset="0"/>
+                <a:ea typeface="Calibri" pitchFamily="34" charset="-122"/>
+                <a:cs typeface="Calibri" pitchFamily="34" charset="-120"/>
+              </a:rPr>
+              <a:t>varias réplicas comparten los hilos (probado con Postgres 16 real)</a:t>
+            </a:r>
+            <a:endParaRPr lang="en-US" sz="1400" dirty="0"/>
           </a:p>
         </p:txBody>
       </p:sp>

</xml_diff>

<commit_message>
docs(agente): diapositiva con la pantalla del agente y capturas regeneradas
Co-Authored-By: Claude Sonnet 5.5 <noreply@anthropic.com>
</commit_message>
<xml_diff>
--- a/docs/agente/Presentacion_EP2_Agente_TodoBarato.pptx
+++ b/docs/agente/Presentacion_EP2_Agente_TodoBarato.pptx
@@ -14,9 +14,10 @@
     <p:sldId id="262" r:id="rId8"/>
     <p:sldId id="263" r:id="rId9"/>
     <p:sldId id="264" r:id="rId10"/>
+    <p:sldId id="265" r:id="rId11"/>
   </p:sldIdLst>
   <p:notesMasterIdLst>
-    <p:notesMasterId r:id="rId11"/>
+    <p:notesMasterId r:id="rId12"/>
   </p:notesMasterIdLst>
   <p:sldSz cx="9144000" cy="5143500"/>
   <p:notesSz cx="5143500" cy="9144000"/>
@@ -115,33 +116,34 @@
   <p:extLst>
     <p:ext uri="{521415D9-36F7-43E2-AB2F-B90AF26B5E84}">
       <p14:sectionLst xmlns:p14="http://schemas.microsoft.com/office/powerpoint/2010/main">
-        <p14:section name="Apertura" id="{e612a812-f61a-55ab-3425-0018cc0bdf9a}">
+        <p14:section name="Apertura" id="{0271e6a5-40b5-d17f-4d7e-01959f08208d}">
           <p14:sldIdLst>
             <p14:sldId id="256"/>
           </p14:sldIdLst>
         </p14:section>
-        <p14:section name="Diseño" id="{26533e28-57f0-1d1c-94f2-69b15cb39ab0}">
+        <p14:section name="Diseño" id="{fbdab523-81a6-b2c6-a7cc-cc160cf1b5ba}">
           <p14:sldIdLst>
             <p14:sldId id="257"/>
             <p14:sldId id="258"/>
             <p14:sldId id="259"/>
           </p14:sldIdLst>
         </p14:section>
-        <p14:section name="Comportamiento" id="{c8f46d86-7439-02c5-f4bf-9872f6cccd7f}">
+        <p14:section name="Comportamiento" id="{db71084d-71ce-f581-22ce-205cb457a9bb}">
           <p14:sldIdLst>
             <p14:sldId id="260"/>
             <p14:sldId id="261"/>
           </p14:sldIdLst>
         </p14:section>
-        <p14:section name="Demostración" id="{551f30eb-38d2-7e4c-4856-7e84ab021532}">
+        <p14:section name="Demostración" id="{1825dc27-7127-1e8f-6557-291eec8934b0}">
           <p14:sldIdLst>
             <p14:sldId id="262"/>
+            <p14:sldId id="263"/>
           </p14:sldIdLst>
         </p14:section>
-        <p14:section name="Cierre" id="{65a547e5-cd4d-e06d-4b93-caf9f1f126c3}">
+        <p14:section name="Cierre" id="{6b64499f-6382-9f80-6cc4-cde7f8f91ce0}">
           <p14:sldIdLst>
-            <p14:sldId id="263"/>
             <p14:sldId id="264"/>
+            <p14:sldId id="265"/>
           </p14:sldIdLst>
         </p14:section>
       </p14:sectionLst>
@@ -590,6 +592,94 @@
 </p:notes>
 </file>
 
+<file path=ppt/notesSlides/notesSlide10.xml><?xml version="1.0" encoding="utf-8"?>
+<p:notes xmlns:a="http://schemas.openxmlformats.org/drawingml/2006/main" xmlns:r="http://schemas.openxmlformats.org/officeDocument/2006/relationships" xmlns:p="http://schemas.openxmlformats.org/presentationml/2006/main">
+  <p:cSld>
+    <p:spTree>
+      <p:nvGrpSpPr>
+        <p:cNvPr id="1" name=""/>
+        <p:cNvGrpSpPr/>
+        <p:nvPr/>
+      </p:nvGrpSpPr>
+      <p:grpSpPr>
+        <a:xfrm>
+          <a:off x="0" y="0"/>
+          <a:ext cx="0" cy="0"/>
+          <a:chOff x="0" y="0"/>
+          <a:chExt cx="0" cy="0"/>
+        </a:xfrm>
+      </p:grpSpPr>
+      <p:sp>
+        <p:nvSpPr>
+          <p:cNvPr id="2" name="Slide Image Placeholder 1"/>
+          <p:cNvSpPr>
+            <a:spLocks noGrp="1" noRot="1" noChangeAspect="1"/>
+          </p:cNvSpPr>
+          <p:nvPr>
+            <p:ph type="sldImg"/>
+          </p:nvPr>
+        </p:nvSpPr>
+        <p:spPr/>
+      </p:sp>
+      <p:sp>
+        <p:nvSpPr>
+          <p:cNvPr id="3" name="Notes Placeholder 2"/>
+          <p:cNvSpPr>
+            <a:spLocks noGrp="1"/>
+          </p:cNvSpPr>
+          <p:nvPr>
+            <p:ph type="body" idx="1"/>
+          </p:nvPr>
+        </p:nvSpPr>
+        <p:spPr/>
+        <p:txBody>
+          <a:bodyPr/>
+          <a:lstStyle/>
+          <a:p>
+            <a:r>
+              <a:rPr lang="en-US" dirty="0"/>
+              <a:t>Presentan ambos. 60 s. Cada fila: decisión y razón medida. Preparar la ronda de preguntas (10 min): por qué LangGraph y no el orquestador propio, por qué reglas deterministas, qué falló con los embeddings locales, qué no se probó (pooler real de Supabase).</a:t>
+            </a:r>
+            <a:endParaRPr lang="en-US" dirty="0"/>
+          </a:p>
+        </p:txBody>
+      </p:sp>
+      <p:sp>
+        <p:nvSpPr>
+          <p:cNvPr id="4" name="Slide Number Placeholder 3"/>
+          <p:cNvSpPr>
+            <a:spLocks noGrp="1"/>
+          </p:cNvSpPr>
+          <p:nvPr>
+            <p:ph type="sldNum" sz="quarter" idx="10"/>
+          </p:nvPr>
+        </p:nvSpPr>
+        <p:spPr/>
+        <p:txBody>
+          <a:bodyPr/>
+          <a:lstStyle/>
+          <a:p>
+            <a:fld id="{F7021451-1387-4CA6-816F-3879F97B5CBC}" type="slidenum">
+              <a:rPr lang="en-US"/>
+              <a:t>10</a:t>
+            </a:fld>
+            <a:endParaRPr lang="en-US"/>
+          </a:p>
+        </p:txBody>
+      </p:sp>
+    </p:spTree>
+    <p:extLst>
+      <p:ext uri="{BB962C8B-B14F-4D97-AF65-F5344CB8AC3E}">
+        <p14:creationId xmlns:p14="http://schemas.microsoft.com/office/powerpoint/2010/main" val="1024086991"/>
+      </p:ext>
+    </p:extLst>
+  </p:cSld>
+  <p:clrMapOvr>
+    <a:masterClrMapping/>
+  </p:clrMapOvr>
+</p:notes>
+</file>
+
 <file path=ppt/notesSlides/notesSlide2.xml><?xml version="1.0" encoding="utf-8"?>
 <p:notes xmlns:a="http://schemas.openxmlformats.org/drawingml/2006/main" xmlns:r="http://schemas.openxmlformats.org/officeDocument/2006/relationships" xmlns:p="http://schemas.openxmlformats.org/presentationml/2006/main">
   <p:cSld>
@@ -1164,7 +1254,7 @@
           <a:p>
             <a:r>
               <a:rPr lang="en-US" dirty="0"/>
-              <a:t>Presenta: Ariel. 45 s. Cifras reales del repositorio. La demo con Gemini completó las historias 1 a 3; la cuota gratuita se agotó en la 4 y el agente lo informó sin caerse. Pruebas en vivo con Gemini y contra Postgres real: pasaron.</a:t>
+              <a:t>Presenta: Ariel. 45 s. Capturas de la pantalla /agente en modo demo. Izquierda: historia 2, el panel «Cómo pensó» muestra el plan, la búsqueda sin resultados y el cambio de estrategia. Derecha: tras simular la baja de precio, la alerta se cumple y queda registrada en «Guardado». Para mostrarla en vivo: backend en el puerto 8000, frontend con pnpm dev y abrir http://localhost:3000/agente.</a:t>
             </a:r>
             <a:endParaRPr lang="en-US" dirty="0"/>
           </a:p>
@@ -1252,7 +1342,7 @@
           <a:p>
             <a:r>
               <a:rPr lang="en-US" dirty="0"/>
-              <a:t>Presentan ambos. 60 s. Cada fila: decisión y razón medida. Preparar la ronda de preguntas (10 min): por qué LangGraph y no el orquestador propio, por qué reglas deterministas, qué falló con los embeddings locales, qué no se probó (pooler real de Supabase).</a:t>
+              <a:t>Presenta: Ariel. 45 s. Cifras reales del repositorio. La demo con Gemini completó las historias 1 a 3; la cuota gratuita se agotó en la 4 y el agente lo informó sin caerse. Pruebas en vivo con Gemini y contra Postgres real: pasaron.</a:t>
             </a:r>
             <a:endParaRPr lang="en-US" dirty="0"/>
           </a:p>
@@ -2002,6 +2092,381 @@
                 <a:cs typeface="Calibri" pitchFamily="34" charset="-120"/>
               </a:rPr>
               <a:t>Nicolas Estefania · Ariel Espinoza</a:t>
+            </a:r>
+            <a:endParaRPr lang="en-US" sz="1400" dirty="0"/>
+          </a:p>
+        </p:txBody>
+      </p:sp>
+    </p:spTree>
+  </p:cSld>
+  <p:clrMapOvr>
+    <a:masterClrMapping/>
+  </p:clrMapOvr>
+</p:sld>
+</file>
+
+<file path=ppt/slides/slide10.xml><?xml version="1.0" encoding="utf-8"?>
+<p:sld xmlns:a="http://schemas.openxmlformats.org/drawingml/2006/main" xmlns:r="http://schemas.openxmlformats.org/officeDocument/2006/relationships" xmlns:p="http://schemas.openxmlformats.org/presentationml/2006/main">
+  <p:cSld name="Slide 10">
+    <p:spTree>
+      <p:nvGrpSpPr>
+        <p:cNvPr id="1" name=""/>
+        <p:cNvGrpSpPr/>
+        <p:nvPr/>
+      </p:nvGrpSpPr>
+      <p:grpSpPr>
+        <a:xfrm>
+          <a:off x="0" y="0"/>
+          <a:ext cx="0" cy="0"/>
+          <a:chOff x="0" y="0"/>
+          <a:chExt cx="0" cy="0"/>
+        </a:xfrm>
+      </p:grpSpPr>
+      <p:sp>
+        <p:nvSpPr>
+          <p:cNvPr id="3" name="Text 0"/>
+          <p:cNvSpPr/>
+          <p:nvPr>
+            <p:ph idx="100" type="title" hasCustomPrompt="1"/>
+          </p:nvPr>
+        </p:nvSpPr>
+        <p:spPr>
+          <a:xfrm>
+            <a:off x="548640" y="1371600"/>
+            <a:ext cx="8046720" cy="1280160"/>
+          </a:xfrm>
+          <a:prstGeom prst="rect">
+            <a:avLst/>
+          </a:prstGeom>
+          <a:noFill/>
+          <a:ln/>
+        </p:spPr>
+        <p:txBody>
+          <a:bodyPr wrap="square" lIns="0" tIns="0" rIns="0" bIns="0" rtlCol="0" anchor="ctr"/>
+          <a:lstStyle/>
+          <a:p>
+            <a:pPr algn="l" indent="0" marL="0">
+              <a:buNone/>
+            </a:pPr>
+            <a:r>
+              <a:rPr lang="en-US" sz="4000" b="1" dirty="0">
+                <a:solidFill>
+                  <a:schemeClr val="bg1"/>
+                </a:solidFill>
+              </a:rPr>
+              <a:t>Por qué estas decisiones</a:t>
+            </a:r>
+            <a:endParaRPr lang="en-US" sz="4000" dirty="0"/>
+          </a:p>
+        </p:txBody>
+      </p:sp>
+      <p:sp>
+        <p:nvSpPr>
+          <p:cNvPr id="4" name="Text 1"/>
+          <p:cNvSpPr txBox="1"/>
+          <p:nvPr/>
+        </p:nvSpPr>
+        <p:spPr>
+          <a:xfrm>
+            <a:off x="548640" y="2514600"/>
+            <a:ext cx="2377440" cy="502920"/>
+          </a:xfrm>
+          <a:prstGeom prst="rect">
+            <a:avLst/>
+          </a:prstGeom>
+          <a:noFill/>
+          <a:ln/>
+        </p:spPr>
+        <p:txBody>
+          <a:bodyPr wrap="square" lIns="0" tIns="0" rIns="0" bIns="0" rtlCol="0" anchor="ctr"/>
+          <a:lstStyle/>
+          <a:p>
+            <a:pPr indent="0" marL="0">
+              <a:buNone/>
+            </a:pPr>
+            <a:r>
+              <a:rPr lang="en-US" sz="1600" b="1" dirty="0">
+                <a:solidFill>
+                  <a:schemeClr val="accent2"/>
+                </a:solidFill>
+                <a:latin typeface="Calibri" pitchFamily="34" charset="0"/>
+                <a:ea typeface="Calibri" pitchFamily="34" charset="-122"/>
+                <a:cs typeface="Calibri" pitchFamily="34" charset="-120"/>
+              </a:rPr>
+              <a:t>LangGraph</a:t>
+            </a:r>
+            <a:endParaRPr lang="en-US" sz="1600" dirty="0"/>
+          </a:p>
+        </p:txBody>
+      </p:sp>
+      <p:sp>
+        <p:nvSpPr>
+          <p:cNvPr id="5" name="Text 2"/>
+          <p:cNvSpPr txBox="1"/>
+          <p:nvPr/>
+        </p:nvSpPr>
+        <p:spPr>
+          <a:xfrm>
+            <a:off x="3017520" y="2514600"/>
+            <a:ext cx="5577840" cy="502920"/>
+          </a:xfrm>
+          <a:prstGeom prst="rect">
+            <a:avLst/>
+          </a:prstGeom>
+          <a:noFill/>
+          <a:ln/>
+        </p:spPr>
+        <p:txBody>
+          <a:bodyPr wrap="square" lIns="0" tIns="0" rIns="0" bIns="0" rtlCol="0" anchor="ctr"/>
+          <a:lstStyle/>
+          <a:p>
+            <a:pPr indent="0" marL="0">
+              <a:buNone/>
+            </a:pPr>
+            <a:r>
+              <a:rPr lang="en-US" sz="1400" dirty="0">
+                <a:solidFill>
+                  <a:schemeClr val="bg1"/>
+                </a:solidFill>
+                <a:latin typeface="Calibri" pitchFamily="34" charset="0"/>
+                <a:ea typeface="Calibri" pitchFamily="34" charset="-122"/>
+                <a:cs typeface="Calibri" pitchFamily="34" charset="-120"/>
+              </a:rPr>
+              <a:t>el flujo tiene ciclo (reflect → plan), estado y checkpointer; el orquestador previo no guardaba estado</a:t>
+            </a:r>
+            <a:endParaRPr lang="en-US" sz="1400" dirty="0"/>
+          </a:p>
+        </p:txBody>
+      </p:sp>
+      <p:sp>
+        <p:nvSpPr>
+          <p:cNvPr id="6" name="Text 3"/>
+          <p:cNvSpPr txBox="1"/>
+          <p:nvPr/>
+        </p:nvSpPr>
+        <p:spPr>
+          <a:xfrm>
+            <a:off x="548640" y="3081528"/>
+            <a:ext cx="2377440" cy="502920"/>
+          </a:xfrm>
+          <a:prstGeom prst="rect">
+            <a:avLst/>
+          </a:prstGeom>
+          <a:noFill/>
+          <a:ln/>
+        </p:spPr>
+        <p:txBody>
+          <a:bodyPr wrap="square" lIns="0" tIns="0" rIns="0" bIns="0" rtlCol="0" anchor="ctr"/>
+          <a:lstStyle/>
+          <a:p>
+            <a:pPr indent="0" marL="0">
+              <a:buNone/>
+            </a:pPr>
+            <a:r>
+              <a:rPr lang="en-US" sz="1600" b="1" dirty="0">
+                <a:solidFill>
+                  <a:schemeClr val="accent2"/>
+                </a:solidFill>
+                <a:latin typeface="Calibri" pitchFamily="34" charset="0"/>
+                <a:ea typeface="Calibri" pitchFamily="34" charset="-122"/>
+                <a:cs typeface="Calibri" pitchFamily="34" charset="-120"/>
+              </a:rPr>
+              <a:t>Reglas en código</a:t>
+            </a:r>
+            <a:endParaRPr lang="en-US" sz="1600" dirty="0"/>
+          </a:p>
+        </p:txBody>
+      </p:sp>
+      <p:sp>
+        <p:nvSpPr>
+          <p:cNvPr id="7" name="Text 4"/>
+          <p:cNvSpPr txBox="1"/>
+          <p:nvPr/>
+        </p:nvSpPr>
+        <p:spPr>
+          <a:xfrm>
+            <a:off x="3017520" y="3081528"/>
+            <a:ext cx="5577840" cy="502920"/>
+          </a:xfrm>
+          <a:prstGeom prst="rect">
+            <a:avLst/>
+          </a:prstGeom>
+          <a:noFill/>
+          <a:ln/>
+        </p:spPr>
+        <p:txBody>
+          <a:bodyPr wrap="square" lIns="0" tIns="0" rIns="0" bIns="0" rtlCol="0" anchor="ctr"/>
+          <a:lstStyle/>
+          <a:p>
+            <a:pPr indent="0" marL="0">
+              <a:buNone/>
+            </a:pPr>
+            <a:r>
+              <a:rPr lang="en-US" sz="1400" dirty="0">
+                <a:solidFill>
+                  <a:schemeClr val="bg1"/>
+                </a:solidFill>
+                <a:latin typeface="Calibri" pitchFamily="34" charset="0"/>
+                <a:ea typeface="Calibri" pitchFamily="34" charset="-122"/>
+                <a:cs typeface="Calibri" pitchFamily="34" charset="-120"/>
+              </a:rPr>
+              <a:t>diagnóstico, tendencia y presupuesto se prueban sin red: 88 pruebas</a:t>
+            </a:r>
+            <a:endParaRPr lang="en-US" sz="1400" dirty="0"/>
+          </a:p>
+        </p:txBody>
+      </p:sp>
+      <p:sp>
+        <p:nvSpPr>
+          <p:cNvPr id="8" name="Text 5"/>
+          <p:cNvSpPr txBox="1"/>
+          <p:nvPr/>
+        </p:nvSpPr>
+        <p:spPr>
+          <a:xfrm>
+            <a:off x="548640" y="3648456"/>
+            <a:ext cx="2377440" cy="502920"/>
+          </a:xfrm>
+          <a:prstGeom prst="rect">
+            <a:avLst/>
+          </a:prstGeom>
+          <a:noFill/>
+          <a:ln/>
+        </p:spPr>
+        <p:txBody>
+          <a:bodyPr wrap="square" lIns="0" tIns="0" rIns="0" bIns="0" rtlCol="0" anchor="ctr"/>
+          <a:lstStyle/>
+          <a:p>
+            <a:pPr indent="0" marL="0">
+              <a:buNone/>
+            </a:pPr>
+            <a:r>
+              <a:rPr lang="en-US" sz="1600" b="1" dirty="0">
+                <a:solidFill>
+                  <a:schemeClr val="accent2"/>
+                </a:solidFill>
+                <a:latin typeface="Calibri" pitchFamily="34" charset="0"/>
+                <a:ea typeface="Calibri" pitchFamily="34" charset="-122"/>
+                <a:cs typeface="Calibri" pitchFamily="34" charset="-120"/>
+              </a:rPr>
+              <a:t>Memoria núcleo</a:t>
+            </a:r>
+            <a:endParaRPr lang="en-US" sz="1600" dirty="0"/>
+          </a:p>
+        </p:txBody>
+      </p:sp>
+      <p:sp>
+        <p:nvSpPr>
+          <p:cNvPr id="9" name="Text 6"/>
+          <p:cNvSpPr txBox="1"/>
+          <p:nvPr/>
+        </p:nvSpPr>
+        <p:spPr>
+          <a:xfrm>
+            <a:off x="3017520" y="3648456"/>
+            <a:ext cx="5577840" cy="502920"/>
+          </a:xfrm>
+          <a:prstGeom prst="rect">
+            <a:avLst/>
+          </a:prstGeom>
+          <a:noFill/>
+          <a:ln/>
+        </p:spPr>
+        <p:txBody>
+          <a:bodyPr wrap="square" lIns="0" tIns="0" rIns="0" bIns="0" rtlCol="0" anchor="ctr"/>
+          <a:lstStyle/>
+          <a:p>
+            <a:pPr indent="0" marL="0">
+              <a:buNone/>
+            </a:pPr>
+            <a:r>
+              <a:rPr lang="en-US" sz="1400" dirty="0">
+                <a:solidFill>
+                  <a:schemeClr val="bg1"/>
+                </a:solidFill>
+                <a:latin typeface="Calibri" pitchFamily="34" charset="0"/>
+                <a:ea typeface="Calibri" pitchFamily="34" charset="-122"/>
+                <a:cs typeface="Calibri" pitchFamily="34" charset="-120"/>
+              </a:rPr>
+              <a:t>con embeddings locales «Recomiéndame un celular» no recuperaba «Prefiero Samsung»</a:t>
+            </a:r>
+            <a:endParaRPr lang="en-US" sz="1400" dirty="0"/>
+          </a:p>
+        </p:txBody>
+      </p:sp>
+      <p:sp>
+        <p:nvSpPr>
+          <p:cNvPr id="10" name="Text 7"/>
+          <p:cNvSpPr txBox="1"/>
+          <p:nvPr/>
+        </p:nvSpPr>
+        <p:spPr>
+          <a:xfrm>
+            <a:off x="548640" y="4215384"/>
+            <a:ext cx="2377440" cy="502920"/>
+          </a:xfrm>
+          <a:prstGeom prst="rect">
+            <a:avLst/>
+          </a:prstGeom>
+          <a:noFill/>
+          <a:ln/>
+        </p:spPr>
+        <p:txBody>
+          <a:bodyPr wrap="square" lIns="0" tIns="0" rIns="0" bIns="0" rtlCol="0" anchor="ctr"/>
+          <a:lstStyle/>
+          <a:p>
+            <a:pPr indent="0" marL="0">
+              <a:buNone/>
+            </a:pPr>
+            <a:r>
+              <a:rPr lang="en-US" sz="1600" b="1" dirty="0">
+                <a:solidFill>
+                  <a:schemeClr val="accent2"/>
+                </a:solidFill>
+                <a:latin typeface="Calibri" pitchFamily="34" charset="0"/>
+                <a:ea typeface="Calibri" pitchFamily="34" charset="-122"/>
+                <a:cs typeface="Calibri" pitchFamily="34" charset="-120"/>
+              </a:rPr>
+              <a:t>Checkpointer Postgres</a:t>
+            </a:r>
+            <a:endParaRPr lang="en-US" sz="1600" dirty="0"/>
+          </a:p>
+        </p:txBody>
+      </p:sp>
+      <p:sp>
+        <p:nvSpPr>
+          <p:cNvPr id="11" name="Text 8"/>
+          <p:cNvSpPr txBox="1"/>
+          <p:nvPr/>
+        </p:nvSpPr>
+        <p:spPr>
+          <a:xfrm>
+            <a:off x="3017520" y="4215384"/>
+            <a:ext cx="5577840" cy="502920"/>
+          </a:xfrm>
+          <a:prstGeom prst="rect">
+            <a:avLst/>
+          </a:prstGeom>
+          <a:noFill/>
+          <a:ln/>
+        </p:spPr>
+        <p:txBody>
+          <a:bodyPr wrap="square" lIns="0" tIns="0" rIns="0" bIns="0" rtlCol="0" anchor="ctr"/>
+          <a:lstStyle/>
+          <a:p>
+            <a:pPr indent="0" marL="0">
+              <a:buNone/>
+            </a:pPr>
+            <a:r>
+              <a:rPr lang="en-US" sz="1400" dirty="0">
+                <a:solidFill>
+                  <a:schemeClr val="bg1"/>
+                </a:solidFill>
+                <a:latin typeface="Calibri" pitchFamily="34" charset="0"/>
+                <a:ea typeface="Calibri" pitchFamily="34" charset="-122"/>
+                <a:cs typeface="Calibri" pitchFamily="34" charset="-120"/>
+              </a:rPr>
+              <a:t>varias réplicas comparten los hilos (probado con Postgres 16 real)</a:t>
             </a:r>
             <a:endParaRPr lang="en-US" sz="1400" dirty="0"/>
           </a:p>
@@ -5919,7 +6384,7 @@
                   <a:schemeClr val="tx2"/>
                 </a:solidFill>
               </a:rPr>
-              <a:t>Evidencia</a:t>
+              <a:t>La pantalla: se ve cómo piensa</a:t>
             </a:r>
             <a:endParaRPr lang="en-US" sz="3000" dirty="0"/>
           </a:p>
@@ -5927,18 +6392,18 @@
       </p:sp>
       <p:sp>
         <p:nvSpPr>
-          <p:cNvPr id="4" name="Cifra pruebas del agente"/>
+          <p:cNvPr id="4" name="Marco captura 1"/>
           <p:cNvSpPr/>
           <p:nvPr/>
         </p:nvSpPr>
         <p:spPr>
           <a:xfrm>
-            <a:off x="457200" y="1188720"/>
-            <a:ext cx="1920240" cy="2011680"/>
+            <a:off x="457200" y="1097280"/>
+            <a:ext cx="4023360" cy="2697480"/>
           </a:xfrm>
           <a:prstGeom prst="roundRect">
             <a:avLst>
-              <a:gd name="adj" fmla="val 4762"/>
+              <a:gd name="adj" fmla="val 3390"/>
             </a:avLst>
           </a:prstGeom>
           <a:solidFill>
@@ -5954,16 +6419,40 @@
           </a:effectLst>
         </p:spPr>
       </p:sp>
-      <p:sp>
-        <p:nvSpPr>
-          <p:cNvPr id="5" name="Text 2"/>
+      <p:pic>
+        <p:nvPicPr>
+          <p:cNvPr id="5" name="Image 0" descr="Plan, herramientas y replanes en vivo">    </p:cNvPr>
+          <p:cNvPicPr>
+            <a:picLocks noChangeAspect="1"/>
+          </p:cNvPicPr>
+          <p:nvPr/>
+        </p:nvPicPr>
+        <p:blipFill>
+          <a:blip r:embed="rId1"/>
+          <a:stretch>
+            <a:fillRect/>
+          </a:stretch>
+        </p:blipFill>
+        <p:spPr>
+          <a:xfrm>
+            <a:off x="548640" y="1188720"/>
+            <a:ext cx="3840480" cy="2400300"/>
+          </a:xfrm>
+          <a:prstGeom prst="rect">
+            <a:avLst/>
+          </a:prstGeom>
+        </p:spPr>
+      </p:pic>
+      <p:sp>
+        <p:nvSpPr>
+          <p:cNvPr id="6" name="Text 2"/>
           <p:cNvSpPr txBox="1"/>
           <p:nvPr/>
         </p:nvSpPr>
         <p:spPr>
           <a:xfrm>
-            <a:off x="457200" y="1325880"/>
-            <a:ext cx="1920240" cy="914400"/>
+            <a:off x="457200" y="3931920"/>
+            <a:ext cx="4023360" cy="365760"/>
           </a:xfrm>
           <a:prstGeom prst="rect">
             <a:avLst/>
@@ -5979,54 +6468,15 @@
               <a:buNone/>
             </a:pPr>
             <a:r>
-              <a:rPr lang="en-US" sz="5400" b="1" dirty="0">
-                <a:solidFill>
-                  <a:schemeClr val="accent1"/>
-                </a:solidFill>
-                <a:latin typeface="Cambria" pitchFamily="34" charset="0"/>
-                <a:ea typeface="Cambria" pitchFamily="34" charset="-122"/>
-                <a:cs typeface="Cambria" pitchFamily="34" charset="-120"/>
-              </a:rPr>
-              <a:t>88</a:t>
-            </a:r>
-            <a:endParaRPr lang="en-US" sz="5400" dirty="0"/>
-          </a:p>
-        </p:txBody>
-      </p:sp>
-      <p:sp>
-        <p:nvSpPr>
-          <p:cNvPr id="6" name="Text 3"/>
-          <p:cNvSpPr txBox="1"/>
-          <p:nvPr/>
-        </p:nvSpPr>
-        <p:spPr>
-          <a:xfrm>
-            <a:off x="594360" y="2286000"/>
-            <a:ext cx="1645920" cy="777240"/>
-          </a:xfrm>
-          <a:prstGeom prst="rect">
-            <a:avLst/>
-          </a:prstGeom>
-          <a:noFill/>
-          <a:ln/>
-        </p:spPr>
-        <p:txBody>
-          <a:bodyPr wrap="square" lIns="0" tIns="0" rIns="0" bIns="0" rtlCol="0" anchor="t"/>
-          <a:lstStyle/>
-          <a:p>
-            <a:pPr algn="ctr" indent="0" marL="0">
-              <a:buNone/>
-            </a:pPr>
-            <a:r>
-              <a:rPr lang="en-US" sz="1400" dirty="0">
-                <a:solidFill>
-                  <a:schemeClr val="tx1"/>
+              <a:rPr lang="en-US" sz="1400" b="1" dirty="0">
+                <a:solidFill>
+                  <a:schemeClr val="tx2"/>
                 </a:solidFill>
                 <a:latin typeface="Calibri" pitchFamily="34" charset="0"/>
                 <a:ea typeface="Calibri" pitchFamily="34" charset="-122"/>
                 <a:cs typeface="Calibri" pitchFamily="34" charset="-120"/>
               </a:rPr>
-              <a:t>pruebas del agente</a:t>
+              <a:t>Plan, herramientas y replanes en vivo</a:t>
             </a:r>
             <a:endParaRPr lang="en-US" sz="1400" dirty="0"/>
           </a:p>
@@ -6034,18 +6484,18 @@
       </p:sp>
       <p:sp>
         <p:nvSpPr>
-          <p:cNvPr id="7" name="Cifra pruebas en todo el repositorio"/>
+          <p:cNvPr id="7" name="Marco captura 2"/>
           <p:cNvSpPr/>
           <p:nvPr/>
         </p:nvSpPr>
         <p:spPr>
           <a:xfrm>
-            <a:off x="2542032" y="1188720"/>
-            <a:ext cx="1920240" cy="2011680"/>
+            <a:off x="4663440" y="1097280"/>
+            <a:ext cx="4023360" cy="2697480"/>
           </a:xfrm>
           <a:prstGeom prst="roundRect">
             <a:avLst>
-              <a:gd name="adj" fmla="val 4762"/>
+              <a:gd name="adj" fmla="val 3390"/>
             </a:avLst>
           </a:prstGeom>
           <a:solidFill>
@@ -6061,16 +6511,40 @@
           </a:effectLst>
         </p:spPr>
       </p:sp>
-      <p:sp>
-        <p:nvSpPr>
-          <p:cNvPr id="8" name="Text 5"/>
+      <p:pic>
+        <p:nvPicPr>
+          <p:cNvPr id="8" name="Image 1" descr="La alerta se cumple y queda guardada">    </p:cNvPr>
+          <p:cNvPicPr>
+            <a:picLocks noChangeAspect="1"/>
+          </p:cNvPicPr>
+          <p:nvPr/>
+        </p:nvPicPr>
+        <p:blipFill>
+          <a:blip r:embed="rId2"/>
+          <a:stretch>
+            <a:fillRect/>
+          </a:stretch>
+        </p:blipFill>
+        <p:spPr>
+          <a:xfrm>
+            <a:off x="4754880" y="1188720"/>
+            <a:ext cx="3840480" cy="2400300"/>
+          </a:xfrm>
+          <a:prstGeom prst="rect">
+            <a:avLst/>
+          </a:prstGeom>
+        </p:spPr>
+      </p:pic>
+      <p:sp>
+        <p:nvSpPr>
+          <p:cNvPr id="9" name="Text 4"/>
           <p:cNvSpPr txBox="1"/>
           <p:nvPr/>
         </p:nvSpPr>
         <p:spPr>
           <a:xfrm>
-            <a:off x="2542032" y="1325880"/>
-            <a:ext cx="1920240" cy="914400"/>
+            <a:off x="4663440" y="3931920"/>
+            <a:ext cx="4023360" cy="365760"/>
           </a:xfrm>
           <a:prstGeom prst="rect">
             <a:avLst/>
@@ -6086,54 +6560,15 @@
               <a:buNone/>
             </a:pPr>
             <a:r>
-              <a:rPr lang="en-US" sz="5400" b="1" dirty="0">
-                <a:solidFill>
-                  <a:schemeClr val="accent1"/>
-                </a:solidFill>
-                <a:latin typeface="Cambria" pitchFamily="34" charset="0"/>
-                <a:ea typeface="Cambria" pitchFamily="34" charset="-122"/>
-                <a:cs typeface="Cambria" pitchFamily="34" charset="-120"/>
-              </a:rPr>
-              <a:t>873</a:t>
-            </a:r>
-            <a:endParaRPr lang="en-US" sz="5400" dirty="0"/>
-          </a:p>
-        </p:txBody>
-      </p:sp>
-      <p:sp>
-        <p:nvSpPr>
-          <p:cNvPr id="9" name="Text 6"/>
-          <p:cNvSpPr txBox="1"/>
-          <p:nvPr/>
-        </p:nvSpPr>
-        <p:spPr>
-          <a:xfrm>
-            <a:off x="2679192" y="2286000"/>
-            <a:ext cx="1645920" cy="777240"/>
-          </a:xfrm>
-          <a:prstGeom prst="rect">
-            <a:avLst/>
-          </a:prstGeom>
-          <a:noFill/>
-          <a:ln/>
-        </p:spPr>
-        <p:txBody>
-          <a:bodyPr wrap="square" lIns="0" tIns="0" rIns="0" bIns="0" rtlCol="0" anchor="t"/>
-          <a:lstStyle/>
-          <a:p>
-            <a:pPr algn="ctr" indent="0" marL="0">
-              <a:buNone/>
-            </a:pPr>
-            <a:r>
-              <a:rPr lang="en-US" sz="1400" dirty="0">
-                <a:solidFill>
-                  <a:schemeClr val="tx1"/>
+              <a:rPr lang="en-US" sz="1400" b="1" dirty="0">
+                <a:solidFill>
+                  <a:schemeClr val="tx2"/>
                 </a:solidFill>
                 <a:latin typeface="Calibri" pitchFamily="34" charset="0"/>
                 <a:ea typeface="Calibri" pitchFamily="34" charset="-122"/>
                 <a:cs typeface="Calibri" pitchFamily="34" charset="-120"/>
               </a:rPr>
-              <a:t>pruebas en todo el repositorio</a:t>
+              <a:t>La alerta se cumple y queda guardada</a:t>
             </a:r>
             <a:endParaRPr lang="en-US" sz="1400" dirty="0"/>
           </a:p>
@@ -6141,43 +6576,14 @@
       </p:sp>
       <p:sp>
         <p:nvSpPr>
-          <p:cNvPr id="10" name="Cifra herramientas: consulta, razonamiento y escritura"/>
-          <p:cNvSpPr/>
-          <p:nvPr/>
-        </p:nvSpPr>
-        <p:spPr>
-          <a:xfrm>
-            <a:off x="4626864" y="1188720"/>
-            <a:ext cx="1920240" cy="2011680"/>
-          </a:xfrm>
-          <a:prstGeom prst="roundRect">
-            <a:avLst>
-              <a:gd name="adj" fmla="val 4762"/>
-            </a:avLst>
-          </a:prstGeom>
-          <a:solidFill>
-            <a:schemeClr val="bg2"/>
-          </a:solidFill>
-          <a:ln/>
-          <a:effectLst>
-            <a:outerShdw sx="100000" sy="100000" kx="0" ky="0" algn="bl" rotWithShape="0" blurRad="76200" dist="25400" dir="5400000">
-              <a:srgbClr val="000000">
-                <a:alpha val="12000"/>
-              </a:srgbClr>
-            </a:outerShdw>
-          </a:effectLst>
-        </p:spPr>
-      </p:sp>
-      <p:sp>
-        <p:nvSpPr>
-          <p:cNvPr id="11" name="Text 8"/>
+          <p:cNvPr id="10" name="Text 5"/>
           <p:cNvSpPr txBox="1"/>
           <p:nvPr/>
         </p:nvSpPr>
         <p:spPr>
           <a:xfrm>
-            <a:off x="4626864" y="1325880"/>
-            <a:ext cx="1920240" cy="914400"/>
+            <a:off x="457200" y="4389120"/>
+            <a:ext cx="8229600" cy="320040"/>
           </a:xfrm>
           <a:prstGeom prst="rect">
             <a:avLst/>
@@ -6187,45 +6593,6 @@
         </p:spPr>
         <p:txBody>
           <a:bodyPr wrap="square" lIns="0" tIns="0" rIns="0" bIns="0" rtlCol="0" anchor="ctr"/>
-          <a:lstStyle/>
-          <a:p>
-            <a:pPr algn="ctr" indent="0" marL="0">
-              <a:buNone/>
-            </a:pPr>
-            <a:r>
-              <a:rPr lang="en-US" sz="5400" b="1" dirty="0">
-                <a:solidFill>
-                  <a:schemeClr val="accent1"/>
-                </a:solidFill>
-                <a:latin typeface="Cambria" pitchFamily="34" charset="0"/>
-                <a:ea typeface="Cambria" pitchFamily="34" charset="-122"/>
-                <a:cs typeface="Cambria" pitchFamily="34" charset="-120"/>
-              </a:rPr>
-              <a:t>11</a:t>
-            </a:r>
-            <a:endParaRPr lang="en-US" sz="5400" dirty="0"/>
-          </a:p>
-        </p:txBody>
-      </p:sp>
-      <p:sp>
-        <p:nvSpPr>
-          <p:cNvPr id="12" name="Text 9"/>
-          <p:cNvSpPr txBox="1"/>
-          <p:nvPr/>
-        </p:nvSpPr>
-        <p:spPr>
-          <a:xfrm>
-            <a:off x="4764024" y="2286000"/>
-            <a:ext cx="1645920" cy="777240"/>
-          </a:xfrm>
-          <a:prstGeom prst="rect">
-            <a:avLst/>
-          </a:prstGeom>
-          <a:noFill/>
-          <a:ln/>
-        </p:spPr>
-        <p:txBody>
-          <a:bodyPr wrap="square" lIns="0" tIns="0" rIns="0" bIns="0" rtlCol="0" anchor="t"/>
           <a:lstStyle/>
           <a:p>
             <a:pPr algn="ctr" indent="0" marL="0">
@@ -6240,210 +6607,9 @@
                 <a:ea typeface="Calibri" pitchFamily="34" charset="-122"/>
                 <a:cs typeface="Calibri" pitchFamily="34" charset="-120"/>
               </a:rPr>
-              <a:t>herramientas: consulta, razonamiento y escritura</a:t>
+              <a:t>Modo demo en http://localhost:3000/agente: sin login y sin gastar cuota</a:t>
             </a:r>
             <a:endParaRPr lang="en-US" sz="1400" dirty="0"/>
-          </a:p>
-        </p:txBody>
-      </p:sp>
-      <p:sp>
-        <p:nvSpPr>
-          <p:cNvPr id="13" name="Cifra diagnósticos que replanifican"/>
-          <p:cNvSpPr/>
-          <p:nvPr/>
-        </p:nvSpPr>
-        <p:spPr>
-          <a:xfrm>
-            <a:off x="6711696" y="1188720"/>
-            <a:ext cx="1920240" cy="2011680"/>
-          </a:xfrm>
-          <a:prstGeom prst="roundRect">
-            <a:avLst>
-              <a:gd name="adj" fmla="val 4762"/>
-            </a:avLst>
-          </a:prstGeom>
-          <a:solidFill>
-            <a:schemeClr val="bg2"/>
-          </a:solidFill>
-          <a:ln/>
-          <a:effectLst>
-            <a:outerShdw sx="100000" sy="100000" kx="0" ky="0" algn="bl" rotWithShape="0" blurRad="76200" dist="25400" dir="5400000">
-              <a:srgbClr val="000000">
-                <a:alpha val="12000"/>
-              </a:srgbClr>
-            </a:outerShdw>
-          </a:effectLst>
-        </p:spPr>
-      </p:sp>
-      <p:sp>
-        <p:nvSpPr>
-          <p:cNvPr id="14" name="Text 11"/>
-          <p:cNvSpPr txBox="1"/>
-          <p:nvPr/>
-        </p:nvSpPr>
-        <p:spPr>
-          <a:xfrm>
-            <a:off x="6711696" y="1325880"/>
-            <a:ext cx="1920240" cy="914400"/>
-          </a:xfrm>
-          <a:prstGeom prst="rect">
-            <a:avLst/>
-          </a:prstGeom>
-          <a:noFill/>
-          <a:ln/>
-        </p:spPr>
-        <p:txBody>
-          <a:bodyPr wrap="square" lIns="0" tIns="0" rIns="0" bIns="0" rtlCol="0" anchor="ctr"/>
-          <a:lstStyle/>
-          <a:p>
-            <a:pPr algn="ctr" indent="0" marL="0">
-              <a:buNone/>
-            </a:pPr>
-            <a:r>
-              <a:rPr lang="en-US" sz="5400" b="1" dirty="0">
-                <a:solidFill>
-                  <a:schemeClr val="accent1"/>
-                </a:solidFill>
-                <a:latin typeface="Cambria" pitchFamily="34" charset="0"/>
-                <a:ea typeface="Cambria" pitchFamily="34" charset="-122"/>
-                <a:cs typeface="Cambria" pitchFamily="34" charset="-120"/>
-              </a:rPr>
-              <a:t>5</a:t>
-            </a:r>
-            <a:endParaRPr lang="en-US" sz="5400" dirty="0"/>
-          </a:p>
-        </p:txBody>
-      </p:sp>
-      <p:sp>
-        <p:nvSpPr>
-          <p:cNvPr id="15" name="Text 12"/>
-          <p:cNvSpPr txBox="1"/>
-          <p:nvPr/>
-        </p:nvSpPr>
-        <p:spPr>
-          <a:xfrm>
-            <a:off x="6848856" y="2286000"/>
-            <a:ext cx="1645920" cy="777240"/>
-          </a:xfrm>
-          <a:prstGeom prst="rect">
-            <a:avLst/>
-          </a:prstGeom>
-          <a:noFill/>
-          <a:ln/>
-        </p:spPr>
-        <p:txBody>
-          <a:bodyPr wrap="square" lIns="0" tIns="0" rIns="0" bIns="0" rtlCol="0" anchor="t"/>
-          <a:lstStyle/>
-          <a:p>
-            <a:pPr algn="ctr" indent="0" marL="0">
-              <a:buNone/>
-            </a:pPr>
-            <a:r>
-              <a:rPr lang="en-US" sz="1400" dirty="0">
-                <a:solidFill>
-                  <a:schemeClr val="tx1"/>
-                </a:solidFill>
-                <a:latin typeface="Calibri" pitchFamily="34" charset="0"/>
-                <a:ea typeface="Calibri" pitchFamily="34" charset="-122"/>
-                <a:cs typeface="Calibri" pitchFamily="34" charset="-120"/>
-              </a:rPr>
-              <a:t>diagnósticos que replanifican</a:t>
-            </a:r>
-            <a:endParaRPr lang="en-US" sz="1400" dirty="0"/>
-          </a:p>
-        </p:txBody>
-      </p:sp>
-      <p:sp>
-        <p:nvSpPr>
-          <p:cNvPr id="16" name="Text 13"/>
-          <p:cNvSpPr txBox="1"/>
-          <p:nvPr/>
-        </p:nvSpPr>
-        <p:spPr>
-          <a:xfrm>
-            <a:off x="457200" y="3520440"/>
-            <a:ext cx="8229600" cy="365760"/>
-          </a:xfrm>
-          <a:prstGeom prst="rect">
-            <a:avLst/>
-          </a:prstGeom>
-          <a:noFill/>
-          <a:ln/>
-        </p:spPr>
-        <p:txBody>
-          <a:bodyPr wrap="square" lIns="0" tIns="0" rIns="0" bIns="0" rtlCol="0" anchor="ctr"/>
-          <a:lstStyle/>
-          <a:p>
-            <a:pPr indent="0" marL="0">
-              <a:buNone/>
-            </a:pPr>
-            <a:r>
-              <a:rPr lang="en-US" sz="1600" b="1" dirty="0">
-                <a:solidFill>
-                  <a:schemeClr val="accent3"/>
-                </a:solidFill>
-              </a:rPr>
-              <a:t>Gemini real: </a:t>
-            </a:r>
-            <a:pPr indent="0" marL="0">
-              <a:buNone/>
-            </a:pPr>
-            <a:r>
-              <a:rPr lang="en-US" sz="1600" dirty="0">
-                <a:solidFill>
-                  <a:schemeClr val="tx1"/>
-                </a:solidFill>
-              </a:rPr>
-              <a:t>historias 1 a 3 completas, con replan por sin_resultados, sobre_presupuesto y precio_alto</a:t>
-            </a:r>
-            <a:endParaRPr lang="en-US" sz="1600" dirty="0"/>
-          </a:p>
-        </p:txBody>
-      </p:sp>
-      <p:sp>
-        <p:nvSpPr>
-          <p:cNvPr id="17" name="Text 14"/>
-          <p:cNvSpPr txBox="1"/>
-          <p:nvPr/>
-        </p:nvSpPr>
-        <p:spPr>
-          <a:xfrm>
-            <a:off x="457200" y="3977640"/>
-            <a:ext cx="8229600" cy="365760"/>
-          </a:xfrm>
-          <a:prstGeom prst="rect">
-            <a:avLst/>
-          </a:prstGeom>
-          <a:noFill/>
-          <a:ln/>
-        </p:spPr>
-        <p:txBody>
-          <a:bodyPr wrap="square" lIns="0" tIns="0" rIns="0" bIns="0" rtlCol="0" anchor="ctr"/>
-          <a:lstStyle/>
-          <a:p>
-            <a:pPr indent="0" marL="0">
-              <a:buNone/>
-            </a:pPr>
-            <a:r>
-              <a:rPr lang="en-US" sz="1600" b="1" dirty="0">
-                <a:solidFill>
-                  <a:schemeClr val="accent3"/>
-                </a:solidFill>
-              </a:rPr>
-              <a:t>Checkpointer: </a:t>
-            </a:r>
-            <a:pPr indent="0" marL="0">
-              <a:buNone/>
-            </a:pPr>
-            <a:r>
-              <a:rPr lang="en-US" sz="1600" dirty="0">
-                <a:solidFill>
-                  <a:schemeClr val="tx1"/>
-                </a:solidFill>
-              </a:rPr>
-              <a:t>dos conexiones distintas comparten un mismo hilo en Postgres 16 real</a:t>
-            </a:r>
-            <a:endParaRPr lang="en-US" sz="1600" dirty="0"/>
           </a:p>
         </p:txBody>
       </p:sp>
@@ -6527,8 +6693,8 @@
         </p:nvSpPr>
         <p:spPr>
           <a:xfrm>
-            <a:off x="548640" y="1371600"/>
-            <a:ext cx="8046720" cy="1280160"/>
+            <a:off x="457200" y="274320"/>
+            <a:ext cx="8229600" cy="640080"/>
           </a:xfrm>
           <a:prstGeom prst="rect">
             <a:avLst/>
@@ -6544,27 +6710,56 @@
               <a:buNone/>
             </a:pPr>
             <a:r>
-              <a:rPr lang="en-US" sz="4000" b="1" dirty="0">
-                <a:solidFill>
-                  <a:schemeClr val="bg1"/>
-                </a:solidFill>
-              </a:rPr>
-              <a:t>Por qué estas decisiones</a:t>
-            </a:r>
-            <a:endParaRPr lang="en-US" sz="4000" dirty="0"/>
-          </a:p>
-        </p:txBody>
-      </p:sp>
-      <p:sp>
-        <p:nvSpPr>
-          <p:cNvPr id="4" name="Text 1"/>
+              <a:rPr lang="en-US" sz="3000" b="1" dirty="0">
+                <a:solidFill>
+                  <a:schemeClr val="tx2"/>
+                </a:solidFill>
+              </a:rPr>
+              <a:t>Evidencia</a:t>
+            </a:r>
+            <a:endParaRPr lang="en-US" sz="3000" dirty="0"/>
+          </a:p>
+        </p:txBody>
+      </p:sp>
+      <p:sp>
+        <p:nvSpPr>
+          <p:cNvPr id="4" name="Cifra pruebas del agente"/>
+          <p:cNvSpPr/>
+          <p:nvPr/>
+        </p:nvSpPr>
+        <p:spPr>
+          <a:xfrm>
+            <a:off x="457200" y="1188720"/>
+            <a:ext cx="1920240" cy="2011680"/>
+          </a:xfrm>
+          <a:prstGeom prst="roundRect">
+            <a:avLst>
+              <a:gd name="adj" fmla="val 4762"/>
+            </a:avLst>
+          </a:prstGeom>
+          <a:solidFill>
+            <a:schemeClr val="bg2"/>
+          </a:solidFill>
+          <a:ln/>
+          <a:effectLst>
+            <a:outerShdw sx="100000" sy="100000" kx="0" ky="0" algn="bl" rotWithShape="0" blurRad="76200" dist="25400" dir="5400000">
+              <a:srgbClr val="000000">
+                <a:alpha val="12000"/>
+              </a:srgbClr>
+            </a:outerShdw>
+          </a:effectLst>
+        </p:spPr>
+      </p:sp>
+      <p:sp>
+        <p:nvSpPr>
+          <p:cNvPr id="5" name="Text 2"/>
           <p:cNvSpPr txBox="1"/>
           <p:nvPr/>
         </p:nvSpPr>
         <p:spPr>
           <a:xfrm>
-            <a:off x="548640" y="2514600"/>
-            <a:ext cx="2377440" cy="502920"/>
+            <a:off x="457200" y="1325880"/>
+            <a:ext cx="1920240" cy="914400"/>
           </a:xfrm>
           <a:prstGeom prst="rect">
             <a:avLst/>
@@ -6576,34 +6771,102 @@
           <a:bodyPr wrap="square" lIns="0" tIns="0" rIns="0" bIns="0" rtlCol="0" anchor="ctr"/>
           <a:lstStyle/>
           <a:p>
-            <a:pPr indent="0" marL="0">
+            <a:pPr algn="ctr" indent="0" marL="0">
               <a:buNone/>
             </a:pPr>
             <a:r>
-              <a:rPr lang="en-US" sz="1600" b="1" dirty="0">
-                <a:solidFill>
-                  <a:schemeClr val="accent2"/>
+              <a:rPr lang="en-US" sz="5400" b="1" dirty="0">
+                <a:solidFill>
+                  <a:schemeClr val="accent1"/>
+                </a:solidFill>
+                <a:latin typeface="Cambria" pitchFamily="34" charset="0"/>
+                <a:ea typeface="Cambria" pitchFamily="34" charset="-122"/>
+                <a:cs typeface="Cambria" pitchFamily="34" charset="-120"/>
+              </a:rPr>
+              <a:t>88</a:t>
+            </a:r>
+            <a:endParaRPr lang="en-US" sz="5400" dirty="0"/>
+          </a:p>
+        </p:txBody>
+      </p:sp>
+      <p:sp>
+        <p:nvSpPr>
+          <p:cNvPr id="6" name="Text 3"/>
+          <p:cNvSpPr txBox="1"/>
+          <p:nvPr/>
+        </p:nvSpPr>
+        <p:spPr>
+          <a:xfrm>
+            <a:off x="594360" y="2286000"/>
+            <a:ext cx="1645920" cy="777240"/>
+          </a:xfrm>
+          <a:prstGeom prst="rect">
+            <a:avLst/>
+          </a:prstGeom>
+          <a:noFill/>
+          <a:ln/>
+        </p:spPr>
+        <p:txBody>
+          <a:bodyPr wrap="square" lIns="0" tIns="0" rIns="0" bIns="0" rtlCol="0" anchor="t"/>
+          <a:lstStyle/>
+          <a:p>
+            <a:pPr algn="ctr" indent="0" marL="0">
+              <a:buNone/>
+            </a:pPr>
+            <a:r>
+              <a:rPr lang="en-US" sz="1400" dirty="0">
+                <a:solidFill>
+                  <a:schemeClr val="tx1"/>
                 </a:solidFill>
                 <a:latin typeface="Calibri" pitchFamily="34" charset="0"/>
                 <a:ea typeface="Calibri" pitchFamily="34" charset="-122"/>
                 <a:cs typeface="Calibri" pitchFamily="34" charset="-120"/>
               </a:rPr>
-              <a:t>LangGraph</a:t>
-            </a:r>
-            <a:endParaRPr lang="en-US" sz="1600" dirty="0"/>
-          </a:p>
-        </p:txBody>
-      </p:sp>
-      <p:sp>
-        <p:nvSpPr>
-          <p:cNvPr id="5" name="Text 2"/>
+              <a:t>pruebas del agente</a:t>
+            </a:r>
+            <a:endParaRPr lang="en-US" sz="1400" dirty="0"/>
+          </a:p>
+        </p:txBody>
+      </p:sp>
+      <p:sp>
+        <p:nvSpPr>
+          <p:cNvPr id="7" name="Cifra pruebas en todo el repositorio"/>
+          <p:cNvSpPr/>
+          <p:nvPr/>
+        </p:nvSpPr>
+        <p:spPr>
+          <a:xfrm>
+            <a:off x="2542032" y="1188720"/>
+            <a:ext cx="1920240" cy="2011680"/>
+          </a:xfrm>
+          <a:prstGeom prst="roundRect">
+            <a:avLst>
+              <a:gd name="adj" fmla="val 4762"/>
+            </a:avLst>
+          </a:prstGeom>
+          <a:solidFill>
+            <a:schemeClr val="bg2"/>
+          </a:solidFill>
+          <a:ln/>
+          <a:effectLst>
+            <a:outerShdw sx="100000" sy="100000" kx="0" ky="0" algn="bl" rotWithShape="0" blurRad="76200" dist="25400" dir="5400000">
+              <a:srgbClr val="000000">
+                <a:alpha val="12000"/>
+              </a:srgbClr>
+            </a:outerShdw>
+          </a:effectLst>
+        </p:spPr>
+      </p:sp>
+      <p:sp>
+        <p:nvSpPr>
+          <p:cNvPr id="8" name="Text 5"/>
           <p:cNvSpPr txBox="1"/>
           <p:nvPr/>
         </p:nvSpPr>
         <p:spPr>
           <a:xfrm>
-            <a:off x="3017520" y="2514600"/>
-            <a:ext cx="5577840" cy="502920"/>
+            <a:off x="2542032" y="1325880"/>
+            <a:ext cx="1920240" cy="914400"/>
           </a:xfrm>
           <a:prstGeom prst="rect">
             <a:avLst/>
@@ -6615,19 +6878,58 @@
           <a:bodyPr wrap="square" lIns="0" tIns="0" rIns="0" bIns="0" rtlCol="0" anchor="ctr"/>
           <a:lstStyle/>
           <a:p>
-            <a:pPr indent="0" marL="0">
+            <a:pPr algn="ctr" indent="0" marL="0">
               <a:buNone/>
             </a:pPr>
             <a:r>
+              <a:rPr lang="en-US" sz="5400" b="1" dirty="0">
+                <a:solidFill>
+                  <a:schemeClr val="accent1"/>
+                </a:solidFill>
+                <a:latin typeface="Cambria" pitchFamily="34" charset="0"/>
+                <a:ea typeface="Cambria" pitchFamily="34" charset="-122"/>
+                <a:cs typeface="Cambria" pitchFamily="34" charset="-120"/>
+              </a:rPr>
+              <a:t>873</a:t>
+            </a:r>
+            <a:endParaRPr lang="en-US" sz="5400" dirty="0"/>
+          </a:p>
+        </p:txBody>
+      </p:sp>
+      <p:sp>
+        <p:nvSpPr>
+          <p:cNvPr id="9" name="Text 6"/>
+          <p:cNvSpPr txBox="1"/>
+          <p:nvPr/>
+        </p:nvSpPr>
+        <p:spPr>
+          <a:xfrm>
+            <a:off x="2679192" y="2286000"/>
+            <a:ext cx="1645920" cy="777240"/>
+          </a:xfrm>
+          <a:prstGeom prst="rect">
+            <a:avLst/>
+          </a:prstGeom>
+          <a:noFill/>
+          <a:ln/>
+        </p:spPr>
+        <p:txBody>
+          <a:bodyPr wrap="square" lIns="0" tIns="0" rIns="0" bIns="0" rtlCol="0" anchor="t"/>
+          <a:lstStyle/>
+          <a:p>
+            <a:pPr algn="ctr" indent="0" marL="0">
+              <a:buNone/>
+            </a:pPr>
+            <a:r>
               <a:rPr lang="en-US" sz="1400" dirty="0">
                 <a:solidFill>
-                  <a:schemeClr val="bg1"/>
+                  <a:schemeClr val="tx1"/>
                 </a:solidFill>
                 <a:latin typeface="Calibri" pitchFamily="34" charset="0"/>
                 <a:ea typeface="Calibri" pitchFamily="34" charset="-122"/>
                 <a:cs typeface="Calibri" pitchFamily="34" charset="-120"/>
               </a:rPr>
-              <a:t>el flujo tiene ciclo (reflect → plan), estado y checkpointer; el orquestador previo no guardaba estado</a:t>
+              <a:t>pruebas en todo el repositorio</a:t>
             </a:r>
             <a:endParaRPr lang="en-US" sz="1400" dirty="0"/>
           </a:p>
@@ -6635,14 +6937,43 @@
       </p:sp>
       <p:sp>
         <p:nvSpPr>
-          <p:cNvPr id="6" name="Text 3"/>
+          <p:cNvPr id="10" name="Cifra herramientas: consulta, razonamiento y escritura"/>
+          <p:cNvSpPr/>
+          <p:nvPr/>
+        </p:nvSpPr>
+        <p:spPr>
+          <a:xfrm>
+            <a:off x="4626864" y="1188720"/>
+            <a:ext cx="1920240" cy="2011680"/>
+          </a:xfrm>
+          <a:prstGeom prst="roundRect">
+            <a:avLst>
+              <a:gd name="adj" fmla="val 4762"/>
+            </a:avLst>
+          </a:prstGeom>
+          <a:solidFill>
+            <a:schemeClr val="bg2"/>
+          </a:solidFill>
+          <a:ln/>
+          <a:effectLst>
+            <a:outerShdw sx="100000" sy="100000" kx="0" ky="0" algn="bl" rotWithShape="0" blurRad="76200" dist="25400" dir="5400000">
+              <a:srgbClr val="000000">
+                <a:alpha val="12000"/>
+              </a:srgbClr>
+            </a:outerShdw>
+          </a:effectLst>
+        </p:spPr>
+      </p:sp>
+      <p:sp>
+        <p:nvSpPr>
+          <p:cNvPr id="11" name="Text 8"/>
           <p:cNvSpPr txBox="1"/>
           <p:nvPr/>
         </p:nvSpPr>
         <p:spPr>
           <a:xfrm>
-            <a:off x="548640" y="3081528"/>
-            <a:ext cx="2377440" cy="502920"/>
+            <a:off x="4626864" y="1325880"/>
+            <a:ext cx="1920240" cy="914400"/>
           </a:xfrm>
           <a:prstGeom prst="rect">
             <a:avLst/>
@@ -6654,34 +6985,102 @@
           <a:bodyPr wrap="square" lIns="0" tIns="0" rIns="0" bIns="0" rtlCol="0" anchor="ctr"/>
           <a:lstStyle/>
           <a:p>
-            <a:pPr indent="0" marL="0">
+            <a:pPr algn="ctr" indent="0" marL="0">
               <a:buNone/>
             </a:pPr>
             <a:r>
-              <a:rPr lang="en-US" sz="1600" b="1" dirty="0">
-                <a:solidFill>
-                  <a:schemeClr val="accent2"/>
+              <a:rPr lang="en-US" sz="5400" b="1" dirty="0">
+                <a:solidFill>
+                  <a:schemeClr val="accent1"/>
+                </a:solidFill>
+                <a:latin typeface="Cambria" pitchFamily="34" charset="0"/>
+                <a:ea typeface="Cambria" pitchFamily="34" charset="-122"/>
+                <a:cs typeface="Cambria" pitchFamily="34" charset="-120"/>
+              </a:rPr>
+              <a:t>11</a:t>
+            </a:r>
+            <a:endParaRPr lang="en-US" sz="5400" dirty="0"/>
+          </a:p>
+        </p:txBody>
+      </p:sp>
+      <p:sp>
+        <p:nvSpPr>
+          <p:cNvPr id="12" name="Text 9"/>
+          <p:cNvSpPr txBox="1"/>
+          <p:nvPr/>
+        </p:nvSpPr>
+        <p:spPr>
+          <a:xfrm>
+            <a:off x="4764024" y="2286000"/>
+            <a:ext cx="1645920" cy="777240"/>
+          </a:xfrm>
+          <a:prstGeom prst="rect">
+            <a:avLst/>
+          </a:prstGeom>
+          <a:noFill/>
+          <a:ln/>
+        </p:spPr>
+        <p:txBody>
+          <a:bodyPr wrap="square" lIns="0" tIns="0" rIns="0" bIns="0" rtlCol="0" anchor="t"/>
+          <a:lstStyle/>
+          <a:p>
+            <a:pPr algn="ctr" indent="0" marL="0">
+              <a:buNone/>
+            </a:pPr>
+            <a:r>
+              <a:rPr lang="en-US" sz="1400" dirty="0">
+                <a:solidFill>
+                  <a:schemeClr val="tx1"/>
                 </a:solidFill>
                 <a:latin typeface="Calibri" pitchFamily="34" charset="0"/>
                 <a:ea typeface="Calibri" pitchFamily="34" charset="-122"/>
                 <a:cs typeface="Calibri" pitchFamily="34" charset="-120"/>
               </a:rPr>
-              <a:t>Reglas en código</a:t>
-            </a:r>
-            <a:endParaRPr lang="en-US" sz="1600" dirty="0"/>
-          </a:p>
-        </p:txBody>
-      </p:sp>
-      <p:sp>
-        <p:nvSpPr>
-          <p:cNvPr id="7" name="Text 4"/>
+              <a:t>herramientas: consulta, razonamiento y escritura</a:t>
+            </a:r>
+            <a:endParaRPr lang="en-US" sz="1400" dirty="0"/>
+          </a:p>
+        </p:txBody>
+      </p:sp>
+      <p:sp>
+        <p:nvSpPr>
+          <p:cNvPr id="13" name="Cifra diagnósticos que replanifican"/>
+          <p:cNvSpPr/>
+          <p:nvPr/>
+        </p:nvSpPr>
+        <p:spPr>
+          <a:xfrm>
+            <a:off x="6711696" y="1188720"/>
+            <a:ext cx="1920240" cy="2011680"/>
+          </a:xfrm>
+          <a:prstGeom prst="roundRect">
+            <a:avLst>
+              <a:gd name="adj" fmla="val 4762"/>
+            </a:avLst>
+          </a:prstGeom>
+          <a:solidFill>
+            <a:schemeClr val="bg2"/>
+          </a:solidFill>
+          <a:ln/>
+          <a:effectLst>
+            <a:outerShdw sx="100000" sy="100000" kx="0" ky="0" algn="bl" rotWithShape="0" blurRad="76200" dist="25400" dir="5400000">
+              <a:srgbClr val="000000">
+                <a:alpha val="12000"/>
+              </a:srgbClr>
+            </a:outerShdw>
+          </a:effectLst>
+        </p:spPr>
+      </p:sp>
+      <p:sp>
+        <p:nvSpPr>
+          <p:cNvPr id="14" name="Text 11"/>
           <p:cNvSpPr txBox="1"/>
           <p:nvPr/>
         </p:nvSpPr>
         <p:spPr>
           <a:xfrm>
-            <a:off x="3017520" y="3081528"/>
-            <a:ext cx="5577840" cy="502920"/>
+            <a:off x="6711696" y="1325880"/>
+            <a:ext cx="1920240" cy="914400"/>
           </a:xfrm>
           <a:prstGeom prst="rect">
             <a:avLst/>
@@ -6693,19 +7092,58 @@
           <a:bodyPr wrap="square" lIns="0" tIns="0" rIns="0" bIns="0" rtlCol="0" anchor="ctr"/>
           <a:lstStyle/>
           <a:p>
-            <a:pPr indent="0" marL="0">
+            <a:pPr algn="ctr" indent="0" marL="0">
               <a:buNone/>
             </a:pPr>
             <a:r>
+              <a:rPr lang="en-US" sz="5400" b="1" dirty="0">
+                <a:solidFill>
+                  <a:schemeClr val="accent1"/>
+                </a:solidFill>
+                <a:latin typeface="Cambria" pitchFamily="34" charset="0"/>
+                <a:ea typeface="Cambria" pitchFamily="34" charset="-122"/>
+                <a:cs typeface="Cambria" pitchFamily="34" charset="-120"/>
+              </a:rPr>
+              <a:t>5</a:t>
+            </a:r>
+            <a:endParaRPr lang="en-US" sz="5400" dirty="0"/>
+          </a:p>
+        </p:txBody>
+      </p:sp>
+      <p:sp>
+        <p:nvSpPr>
+          <p:cNvPr id="15" name="Text 12"/>
+          <p:cNvSpPr txBox="1"/>
+          <p:nvPr/>
+        </p:nvSpPr>
+        <p:spPr>
+          <a:xfrm>
+            <a:off x="6848856" y="2286000"/>
+            <a:ext cx="1645920" cy="777240"/>
+          </a:xfrm>
+          <a:prstGeom prst="rect">
+            <a:avLst/>
+          </a:prstGeom>
+          <a:noFill/>
+          <a:ln/>
+        </p:spPr>
+        <p:txBody>
+          <a:bodyPr wrap="square" lIns="0" tIns="0" rIns="0" bIns="0" rtlCol="0" anchor="t"/>
+          <a:lstStyle/>
+          <a:p>
+            <a:pPr algn="ctr" indent="0" marL="0">
+              <a:buNone/>
+            </a:pPr>
+            <a:r>
               <a:rPr lang="en-US" sz="1400" dirty="0">
                 <a:solidFill>
-                  <a:schemeClr val="bg1"/>
+                  <a:schemeClr val="tx1"/>
                 </a:solidFill>
                 <a:latin typeface="Calibri" pitchFamily="34" charset="0"/>
                 <a:ea typeface="Calibri" pitchFamily="34" charset="-122"/>
                 <a:cs typeface="Calibri" pitchFamily="34" charset="-120"/>
               </a:rPr>
-              <a:t>diagnóstico, tendencia y presupuesto se prueban sin red: 88 pruebas</a:t>
+              <a:t>diagnósticos que replanifican</a:t>
             </a:r>
             <a:endParaRPr lang="en-US" sz="1400" dirty="0"/>
           </a:p>
@@ -6713,14 +7151,14 @@
       </p:sp>
       <p:sp>
         <p:nvSpPr>
-          <p:cNvPr id="8" name="Text 5"/>
+          <p:cNvPr id="16" name="Text 13"/>
           <p:cNvSpPr txBox="1"/>
           <p:nvPr/>
         </p:nvSpPr>
         <p:spPr>
           <a:xfrm>
-            <a:off x="548640" y="3648456"/>
-            <a:ext cx="2377440" cy="502920"/>
+            <a:off x="457200" y="3520440"/>
+            <a:ext cx="8229600" cy="365760"/>
           </a:xfrm>
           <a:prstGeom prst="rect">
             <a:avLst/>
@@ -6738,67 +7176,36 @@
             <a:r>
               <a:rPr lang="en-US" sz="1600" b="1" dirty="0">
                 <a:solidFill>
-                  <a:schemeClr val="accent2"/>
-                </a:solidFill>
-                <a:latin typeface="Calibri" pitchFamily="34" charset="0"/>
-                <a:ea typeface="Calibri" pitchFamily="34" charset="-122"/>
-                <a:cs typeface="Calibri" pitchFamily="34" charset="-120"/>
-              </a:rPr>
-              <a:t>Memoria núcleo</a:t>
-            </a:r>
-            <a:endParaRPr lang="en-US" sz="1600" dirty="0"/>
-          </a:p>
-        </p:txBody>
-      </p:sp>
-      <p:sp>
-        <p:nvSpPr>
-          <p:cNvPr id="9" name="Text 6"/>
-          <p:cNvSpPr txBox="1"/>
-          <p:nvPr/>
-        </p:nvSpPr>
-        <p:spPr>
-          <a:xfrm>
-            <a:off x="3017520" y="3648456"/>
-            <a:ext cx="5577840" cy="502920"/>
-          </a:xfrm>
-          <a:prstGeom prst="rect">
-            <a:avLst/>
-          </a:prstGeom>
-          <a:noFill/>
-          <a:ln/>
-        </p:spPr>
-        <p:txBody>
-          <a:bodyPr wrap="square" lIns="0" tIns="0" rIns="0" bIns="0" rtlCol="0" anchor="ctr"/>
-          <a:lstStyle/>
-          <a:p>
+                  <a:schemeClr val="accent3"/>
+                </a:solidFill>
+              </a:rPr>
+              <a:t>Gemini real: </a:t>
+            </a:r>
             <a:pPr indent="0" marL="0">
               <a:buNone/>
             </a:pPr>
             <a:r>
-              <a:rPr lang="en-US" sz="1400" dirty="0">
-                <a:solidFill>
-                  <a:schemeClr val="bg1"/>
-                </a:solidFill>
-                <a:latin typeface="Calibri" pitchFamily="34" charset="0"/>
-                <a:ea typeface="Calibri" pitchFamily="34" charset="-122"/>
-                <a:cs typeface="Calibri" pitchFamily="34" charset="-120"/>
-              </a:rPr>
-              <a:t>con embeddings locales «Recomiéndame un celular» no recuperaba «Prefiero Samsung»</a:t>
-            </a:r>
-            <a:endParaRPr lang="en-US" sz="1400" dirty="0"/>
-          </a:p>
-        </p:txBody>
-      </p:sp>
-      <p:sp>
-        <p:nvSpPr>
-          <p:cNvPr id="10" name="Text 7"/>
+              <a:rPr lang="en-US" sz="1600" dirty="0">
+                <a:solidFill>
+                  <a:schemeClr val="tx1"/>
+                </a:solidFill>
+              </a:rPr>
+              <a:t>historias 1 a 3 completas, con replan por sin_resultados, sobre_presupuesto y precio_alto</a:t>
+            </a:r>
+            <a:endParaRPr lang="en-US" sz="1600" dirty="0"/>
+          </a:p>
+        </p:txBody>
+      </p:sp>
+      <p:sp>
+        <p:nvSpPr>
+          <p:cNvPr id="17" name="Text 14"/>
           <p:cNvSpPr txBox="1"/>
           <p:nvPr/>
         </p:nvSpPr>
         <p:spPr>
           <a:xfrm>
-            <a:off x="548640" y="4215384"/>
-            <a:ext cx="2377440" cy="502920"/>
+            <a:off x="457200" y="3977640"/>
+            <a:ext cx="8229600" cy="365760"/>
           </a:xfrm>
           <a:prstGeom prst="rect">
             <a:avLst/>
@@ -6816,54 +7223,68 @@
             <a:r>
               <a:rPr lang="en-US" sz="1600" b="1" dirty="0">
                 <a:solidFill>
-                  <a:schemeClr val="accent2"/>
-                </a:solidFill>
-                <a:latin typeface="Calibri" pitchFamily="34" charset="0"/>
-                <a:ea typeface="Calibri" pitchFamily="34" charset="-122"/>
-                <a:cs typeface="Calibri" pitchFamily="34" charset="-120"/>
-              </a:rPr>
-              <a:t>Checkpointer Postgres</a:t>
-            </a:r>
-            <a:endParaRPr lang="en-US" sz="1600" dirty="0"/>
-          </a:p>
-        </p:txBody>
-      </p:sp>
-      <p:sp>
-        <p:nvSpPr>
-          <p:cNvPr id="11" name="Text 8"/>
-          <p:cNvSpPr txBox="1"/>
-          <p:nvPr/>
-        </p:nvSpPr>
-        <p:spPr>
-          <a:xfrm>
-            <a:off x="3017520" y="4215384"/>
-            <a:ext cx="5577840" cy="502920"/>
-          </a:xfrm>
-          <a:prstGeom prst="rect">
-            <a:avLst/>
-          </a:prstGeom>
-          <a:noFill/>
-          <a:ln/>
-        </p:spPr>
-        <p:txBody>
-          <a:bodyPr wrap="square" lIns="0" tIns="0" rIns="0" bIns="0" rtlCol="0" anchor="ctr"/>
-          <a:lstStyle/>
-          <a:p>
+                  <a:schemeClr val="accent3"/>
+                </a:solidFill>
+              </a:rPr>
+              <a:t>Checkpointer: </a:t>
+            </a:r>
             <a:pPr indent="0" marL="0">
               <a:buNone/>
             </a:pPr>
             <a:r>
-              <a:rPr lang="en-US" sz="1400" dirty="0">
-                <a:solidFill>
-                  <a:schemeClr val="bg1"/>
-                </a:solidFill>
-                <a:latin typeface="Calibri" pitchFamily="34" charset="0"/>
-                <a:ea typeface="Calibri" pitchFamily="34" charset="-122"/>
-                <a:cs typeface="Calibri" pitchFamily="34" charset="-120"/>
-              </a:rPr>
-              <a:t>varias réplicas comparten los hilos (probado con Postgres 16 real)</a:t>
-            </a:r>
-            <a:endParaRPr lang="en-US" sz="1400" dirty="0"/>
+              <a:rPr lang="en-US" sz="1600" dirty="0">
+                <a:solidFill>
+                  <a:schemeClr val="tx1"/>
+                </a:solidFill>
+              </a:rPr>
+              <a:t>dos conexiones distintas comparten un mismo hilo en Postgres 16 real</a:t>
+            </a:r>
+            <a:endParaRPr lang="en-US" sz="1600" dirty="0"/>
+          </a:p>
+        </p:txBody>
+      </p:sp>
+      <p:sp>
+        <p:nvSpPr>
+          <p:cNvPr id="25" name="Slide Number Placeholder 0"/>
+          <p:cNvSpPr>
+            <a:spLocks noGrp="1"/>
+          </p:cNvSpPr>
+          <p:nvPr>
+            <p:ph type="sldNum" sz="quarter" idx="4294967295"/>
+          </p:nvPr>
+        </p:nvSpPr>
+        <p:spPr>
+          <a:xfrm>
+            <a:off x="8321040" y="4800600"/>
+            <a:ext cx="457200" cy="274320"/>
+          </a:xfrm>
+          <a:prstGeom prst="rect">
+            <a:avLst/>
+          </a:prstGeom>
+          <a:extLst>
+            <a:ext uri="{C572A759-6A51-4108-AA02-DFA0A04FC94B}">
+              <ma14:wrappingTextBoxFlag xmlns:ma14="http://schemas.microsoft.com/office/mac/drawingml/2011/main" val="0"/>
+            </a:ext>
+          </a:extLst>
+        </p:spPr>
+        <p:txBody>
+          <a:bodyPr/>
+          <a:lstStyle>
+            <a:lvl1pPr>
+              <a:defRPr sz="1000">
+                <a:solidFill>
+                  <a:schemeClr val="accent1"/>
+                </a:solidFill>
+              </a:defRPr>
+            </a:lvl1pPr>
+          </a:lstStyle>
+          <a:p>
+            <a:pPr algn="l"/>
+            <a:fld id="{F7021451-1387-4CA6-816F-3879F97B5CBC}" type="slidenum">
+              <a:rPr b="0" lang="en-US"/>
+              <a:t>9</a:t>
+            </a:fld>
+            <a:endParaRPr lang="en-US"/>
           </a:p>
         </p:txBody>
       </p:sp>

</xml_diff>

<commit_message>
feat(agente): ocultar el modo Demo; solo se abre con /agente?demo=1
La pantalla pública usa solo Gemini real (sin selector ni avisos de demo). Con ?demo=1 aparece
el selector Demo / Gemini real, siempre que el backend tenga la demo encendida. README y
presentación actualizados.

Co-Authored-By: Claude Sonnet 5.5 <noreply@anthropic.com>
</commit_message>
<xml_diff>
--- a/docs/agente/Presentacion_EP2_Agente_TodoBarato.pptx
+++ b/docs/agente/Presentacion_EP2_Agente_TodoBarato.pptx
@@ -116,31 +116,31 @@
   <p:extLst>
     <p:ext uri="{521415D9-36F7-43E2-AB2F-B90AF26B5E84}">
       <p14:sectionLst xmlns:p14="http://schemas.microsoft.com/office/powerpoint/2010/main">
-        <p14:section name="Apertura" id="{0271e6a5-40b5-d17f-4d7e-01959f08208d}">
+        <p14:section name="Apertura" id="{e1216ebd-0070-6b56-5e65-e0fe532391e0}">
           <p14:sldIdLst>
             <p14:sldId id="256"/>
           </p14:sldIdLst>
         </p14:section>
-        <p14:section name="Diseño" id="{fbdab523-81a6-b2c6-a7cc-cc160cf1b5ba}">
+        <p14:section name="Diseño" id="{39f60a36-2ae4-f76a-4045-c3b28e57e01a}">
           <p14:sldIdLst>
             <p14:sldId id="257"/>
             <p14:sldId id="258"/>
             <p14:sldId id="259"/>
           </p14:sldIdLst>
         </p14:section>
-        <p14:section name="Comportamiento" id="{db71084d-71ce-f581-22ce-205cb457a9bb}">
+        <p14:section name="Comportamiento" id="{85096e05-4263-1b5b-6bea-51bf18a99fe5}">
           <p14:sldIdLst>
             <p14:sldId id="260"/>
             <p14:sldId id="261"/>
           </p14:sldIdLst>
         </p14:section>
-        <p14:section name="Demostración" id="{1825dc27-7127-1e8f-6557-291eec8934b0}">
+        <p14:section name="Demostración" id="{d252b8d0-0393-4885-1035-cf045dd2d57a}">
           <p14:sldIdLst>
             <p14:sldId id="262"/>
             <p14:sldId id="263"/>
           </p14:sldIdLst>
         </p14:section>
-        <p14:section name="Cierre" id="{6b64499f-6382-9f80-6cc4-cde7f8f91ce0}">
+        <p14:section name="Cierre" id="{b623fd6c-9784-4d7b-bb72-b871bb97367a}">
           <p14:sldIdLst>
             <p14:sldId id="264"/>
             <p14:sldId id="265"/>
@@ -1254,7 +1254,7 @@
           <a:p>
             <a:r>
               <a:rPr lang="en-US" dirty="0"/>
-              <a:t>Presenta: Ariel. 45 s. Capturas de la pantalla /agente en modo demo. Izquierda: historia 2, el panel «Cómo pensó» muestra el plan, la búsqueda sin resultados y el cambio de estrategia. Derecha: tras simular la baja de precio, la alerta se cumple y queda registrada en «Guardado». Para mostrarla en vivo: backend en el puerto 8000, frontend con pnpm dev y abrir http://localhost:3000/agente.</a:t>
+              <a:t>Presenta: Ariel. 45 s. Capturas de la pantalla /agente en modo demo (se abre con /agente?demo=1; sin ese parámetro la pantalla usa Gemini real). Izquierda: historia 2, el panel «Cómo pensó» muestra el plan, la búsqueda sin resultados y el cambio de estrategia. Derecha: tras simular la baja de precio, la alerta se cumple y queda registrada en «Guardado». Para mostrarla en vivo: backend en el puerto 8000, frontend con pnpm dev y abrir http://localhost:3000/agente?demo=1.</a:t>
             </a:r>
             <a:endParaRPr lang="en-US" dirty="0"/>
           </a:p>
@@ -6607,7 +6607,7 @@
                 <a:ea typeface="Calibri" pitchFamily="34" charset="-122"/>
                 <a:cs typeface="Calibri" pitchFamily="34" charset="-120"/>
               </a:rPr>
-              <a:t>Modo demo en http://localhost:3000/agente: sin login y sin gastar cuota</a:t>
+              <a:t>Modo demo en http://localhost:3000/agente?demo=1: sin login y sin gastar cuota</a:t>
             </a:r>
             <a:endParaRPr lang="en-US" sz="1400" dirty="0"/>
           </a:p>

</xml_diff>

<commit_message>
feat(agente): ocultar el modo Demo; solo se abre con /agente?demo=1 (#6)
La pantalla pública usa solo Gemini real (sin selector ni avisos de demo). Con ?demo=1 aparece
el selector Demo / Gemini real, siempre que el backend tenga la demo encendida. README y
presentación actualizados.

Co-authored-by: nikocode <nicolasestefaniad@gmail.com>
Co-authored-by: Claude Sonnet 5.5 <noreply@anthropic.com>
</commit_message>
<xml_diff>
--- a/docs/agente/Presentacion_EP2_Agente_TodoBarato.pptx
+++ b/docs/agente/Presentacion_EP2_Agente_TodoBarato.pptx
@@ -116,31 +116,31 @@
   <p:extLst>
     <p:ext uri="{521415D9-36F7-43E2-AB2F-B90AF26B5E84}">
       <p14:sectionLst xmlns:p14="http://schemas.microsoft.com/office/powerpoint/2010/main">
-        <p14:section name="Apertura" id="{0271e6a5-40b5-d17f-4d7e-01959f08208d}">
+        <p14:section name="Apertura" id="{e1216ebd-0070-6b56-5e65-e0fe532391e0}">
           <p14:sldIdLst>
             <p14:sldId id="256"/>
           </p14:sldIdLst>
         </p14:section>
-        <p14:section name="Diseño" id="{fbdab523-81a6-b2c6-a7cc-cc160cf1b5ba}">
+        <p14:section name="Diseño" id="{39f60a36-2ae4-f76a-4045-c3b28e57e01a}">
           <p14:sldIdLst>
             <p14:sldId id="257"/>
             <p14:sldId id="258"/>
             <p14:sldId id="259"/>
           </p14:sldIdLst>
         </p14:section>
-        <p14:section name="Comportamiento" id="{db71084d-71ce-f581-22ce-205cb457a9bb}">
+        <p14:section name="Comportamiento" id="{85096e05-4263-1b5b-6bea-51bf18a99fe5}">
           <p14:sldIdLst>
             <p14:sldId id="260"/>
             <p14:sldId id="261"/>
           </p14:sldIdLst>
         </p14:section>
-        <p14:section name="Demostración" id="{1825dc27-7127-1e8f-6557-291eec8934b0}">
+        <p14:section name="Demostración" id="{d252b8d0-0393-4885-1035-cf045dd2d57a}">
           <p14:sldIdLst>
             <p14:sldId id="262"/>
             <p14:sldId id="263"/>
           </p14:sldIdLst>
         </p14:section>
-        <p14:section name="Cierre" id="{6b64499f-6382-9f80-6cc4-cde7f8f91ce0}">
+        <p14:section name="Cierre" id="{b623fd6c-9784-4d7b-bb72-b871bb97367a}">
           <p14:sldIdLst>
             <p14:sldId id="264"/>
             <p14:sldId id="265"/>
@@ -1254,7 +1254,7 @@
           <a:p>
             <a:r>
               <a:rPr lang="en-US" dirty="0"/>
-              <a:t>Presenta: Ariel. 45 s. Capturas de la pantalla /agente en modo demo. Izquierda: historia 2, el panel «Cómo pensó» muestra el plan, la búsqueda sin resultados y el cambio de estrategia. Derecha: tras simular la baja de precio, la alerta se cumple y queda registrada en «Guardado». Para mostrarla en vivo: backend en el puerto 8000, frontend con pnpm dev y abrir http://localhost:3000/agente.</a:t>
+              <a:t>Presenta: Ariel. 45 s. Capturas de la pantalla /agente en modo demo (se abre con /agente?demo=1; sin ese parámetro la pantalla usa Gemini real). Izquierda: historia 2, el panel «Cómo pensó» muestra el plan, la búsqueda sin resultados y el cambio de estrategia. Derecha: tras simular la baja de precio, la alerta se cumple y queda registrada en «Guardado». Para mostrarla en vivo: backend en el puerto 8000, frontend con pnpm dev y abrir http://localhost:3000/agente?demo=1.</a:t>
             </a:r>
             <a:endParaRPr lang="en-US" dirty="0"/>
           </a:p>
@@ -6607,7 +6607,7 @@
                 <a:ea typeface="Calibri" pitchFamily="34" charset="-122"/>
                 <a:cs typeface="Calibri" pitchFamily="34" charset="-120"/>
               </a:rPr>
-              <a:t>Modo demo en http://localhost:3000/agente: sin login y sin gastar cuota</a:t>
+              <a:t>Modo demo en http://localhost:3000/agente?demo=1: sin login y sin gastar cuota</a:t>
             </a:r>
             <a:endParaRPr lang="en-US" sz="1400" dirty="0"/>
           </a:p>

</xml_diff>

<commit_message>
fix(agente): guardar listas solo si se piden, limpiar puntuación suelta y usar capturas reales en la presentación
- save_shopping_list ahora es una regla en código: si el pedido no menciona lista/guardar/armar/anotar,
  no guarda nada y le dice al modelo que ofrezca guardarla (Gemini ignoraba la instrucción del prompt).
  La escritura rechazada no cuenta como escritura ni dispara un replan.
- La respuesta ya no empieza con puntuación suelta (".He revisado…").
- Diapositiva 8 con capturas reales de /agente (Gemini y catálogo reales) en vez de las de la demo.

Co-Authored-By: Claude Sonnet 5.5 <noreply@anthropic.com>
</commit_message>
<xml_diff>
--- a/docs/agente/Presentacion_EP2_Agente_TodoBarato.pptx
+++ b/docs/agente/Presentacion_EP2_Agente_TodoBarato.pptx
@@ -116,31 +116,31 @@
   <p:extLst>
     <p:ext uri="{521415D9-36F7-43E2-AB2F-B90AF26B5E84}">
       <p14:sectionLst xmlns:p14="http://schemas.microsoft.com/office/powerpoint/2010/main">
-        <p14:section name="Apertura" id="{e1216ebd-0070-6b56-5e65-e0fe532391e0}">
+        <p14:section name="Apertura" id="{dac7d5ba-85e2-ba81-386d-72d24eed0ed1}">
           <p14:sldIdLst>
             <p14:sldId id="256"/>
           </p14:sldIdLst>
         </p14:section>
-        <p14:section name="Diseño" id="{39f60a36-2ae4-f76a-4045-c3b28e57e01a}">
+        <p14:section name="Diseño" id="{46b5a94e-aaeb-3785-5c4b-a43d6c793877}">
           <p14:sldIdLst>
             <p14:sldId id="257"/>
             <p14:sldId id="258"/>
             <p14:sldId id="259"/>
           </p14:sldIdLst>
         </p14:section>
-        <p14:section name="Comportamiento" id="{85096e05-4263-1b5b-6bea-51bf18a99fe5}">
+        <p14:section name="Comportamiento" id="{98f8e07d-934a-1001-8a01-8d72e042b93f}">
           <p14:sldIdLst>
             <p14:sldId id="260"/>
             <p14:sldId id="261"/>
           </p14:sldIdLst>
         </p14:section>
-        <p14:section name="Demostración" id="{d252b8d0-0393-4885-1035-cf045dd2d57a}">
+        <p14:section name="Demostración" id="{7dc20ede-9775-b461-7ea4-9a971af367d1}">
           <p14:sldIdLst>
             <p14:sldId id="262"/>
             <p14:sldId id="263"/>
           </p14:sldIdLst>
         </p14:section>
-        <p14:section name="Cierre" id="{b623fd6c-9784-4d7b-bb72-b871bb97367a}">
+        <p14:section name="Cierre" id="{fff423d0-f37c-9be9-b5f1-701f3c844a32}">
           <p14:sldIdLst>
             <p14:sldId id="264"/>
             <p14:sldId id="265"/>
@@ -1254,7 +1254,7 @@
           <a:p>
             <a:r>
               <a:rPr lang="en-US" dirty="0"/>
-              <a:t>Presenta: Ariel. 45 s. Capturas de la pantalla /agente en modo demo (se abre con /agente?demo=1; sin ese parámetro la pantalla usa Gemini real). Izquierda: historia 2, el panel «Cómo pensó» muestra el plan, la búsqueda sin resultados y el cambio de estrategia. Derecha: tras simular la baja de precio, la alerta se cumple y queda registrada en «Guardado». Para mostrarla en vivo: backend en el puerto 8000, frontend con pnpm dev y abrir http://localhost:3000/agente?demo=1.</a:t>
+              <a:t>Presenta: Ariel. 45 s. Capturas reales de /agente con Gemini y el catálogo real de Supabase. Izquierda: el pedido del HP Victus ($1.336.540) supera el presupuesto de $1.000.000; en «Cómo pensó» se ve el recuadro naranja del replan y la alerta creada (marca ESCRIBE). Derecha: en una conversación nueva, «Revisa mis alertas» encuentra la alerta y, en «Memoria que usó», recuerda la preferencia por Samsung y la tarea anterior. Para mostrarlo en vivo: backend en el puerto 8000, frontend con pnpm dev e iniciar sesión en http://localhost:3000/agente. Respaldo sin Gemini ni login: /agente?demo=1.</a:t>
             </a:r>
             <a:endParaRPr lang="en-US" dirty="0"/>
           </a:p>
@@ -6399,11 +6399,11 @@
         <p:spPr>
           <a:xfrm>
             <a:off x="457200" y="1097280"/>
-            <a:ext cx="4023360" cy="2697480"/>
+            <a:ext cx="4023360" cy="2103120"/>
           </a:xfrm>
           <a:prstGeom prst="roundRect">
             <a:avLst>
-              <a:gd name="adj" fmla="val 3390"/>
+              <a:gd name="adj" fmla="val 4348"/>
             </a:avLst>
           </a:prstGeom>
           <a:solidFill>
@@ -6421,7 +6421,7 @@
       </p:sp>
       <p:pic>
         <p:nvPicPr>
-          <p:cNvPr id="5" name="Image 0" descr="Plan, herramientas y replanes en vivo">    </p:cNvPr>
+          <p:cNvPr id="5" name="Image 0" descr="Replanifica y crea la alerta">    </p:cNvPr>
           <p:cNvPicPr>
             <a:picLocks noChangeAspect="1"/>
           </p:cNvPicPr>
@@ -6436,7 +6436,7 @@
         <p:spPr>
           <a:xfrm>
             <a:off x="548640" y="1188720"/>
-            <a:ext cx="3840480" cy="2400300"/>
+            <a:ext cx="3840480" cy="1836115"/>
           </a:xfrm>
           <a:prstGeom prst="rect">
             <a:avLst/>
@@ -6451,7 +6451,7 @@
         </p:nvSpPr>
         <p:spPr>
           <a:xfrm>
-            <a:off x="457200" y="3931920"/>
+            <a:off x="457200" y="3291840"/>
             <a:ext cx="4023360" cy="365760"/>
           </a:xfrm>
           <a:prstGeom prst="rect">
@@ -6476,7 +6476,7 @@
                 <a:ea typeface="Calibri" pitchFamily="34" charset="-122"/>
                 <a:cs typeface="Calibri" pitchFamily="34" charset="-120"/>
               </a:rPr>
-              <a:t>Plan, herramientas y replanes en vivo</a:t>
+              <a:t>Replanifica y crea la alerta</a:t>
             </a:r>
             <a:endParaRPr lang="en-US" sz="1400" dirty="0"/>
           </a:p>
@@ -6491,11 +6491,11 @@
         <p:spPr>
           <a:xfrm>
             <a:off x="4663440" y="1097280"/>
-            <a:ext cx="4023360" cy="2697480"/>
+            <a:ext cx="4023360" cy="2103120"/>
           </a:xfrm>
           <a:prstGeom prst="roundRect">
             <a:avLst>
-              <a:gd name="adj" fmla="val 3390"/>
+              <a:gd name="adj" fmla="val 4348"/>
             </a:avLst>
           </a:prstGeom>
           <a:solidFill>
@@ -6513,7 +6513,7 @@
       </p:sp>
       <p:pic>
         <p:nvPicPr>
-          <p:cNvPr id="8" name="Image 1" descr="La alerta se cumple y queda guardada">    </p:cNvPr>
+          <p:cNvPr id="8" name="Image 1" descr="Revisa la alerta y usa su memoria">    </p:cNvPr>
           <p:cNvPicPr>
             <a:picLocks noChangeAspect="1"/>
           </p:cNvPicPr>
@@ -6528,7 +6528,7 @@
         <p:spPr>
           <a:xfrm>
             <a:off x="4754880" y="1188720"/>
-            <a:ext cx="3840480" cy="2400300"/>
+            <a:ext cx="3840480" cy="1836115"/>
           </a:xfrm>
           <a:prstGeom prst="rect">
             <a:avLst/>
@@ -6543,7 +6543,7 @@
         </p:nvSpPr>
         <p:spPr>
           <a:xfrm>
-            <a:off x="4663440" y="3931920"/>
+            <a:off x="4663440" y="3291840"/>
             <a:ext cx="4023360" cy="365760"/>
           </a:xfrm>
           <a:prstGeom prst="rect">
@@ -6568,7 +6568,7 @@
                 <a:ea typeface="Calibri" pitchFamily="34" charset="-122"/>
                 <a:cs typeface="Calibri" pitchFamily="34" charset="-120"/>
               </a:rPr>
-              <a:t>La alerta se cumple y queda guardada</a:t>
+              <a:t>Revisa la alerta y usa su memoria</a:t>
             </a:r>
             <a:endParaRPr lang="en-US" sz="1400" dirty="0"/>
           </a:p>
@@ -6582,8 +6582,8 @@
         </p:nvSpPr>
         <p:spPr>
           <a:xfrm>
-            <a:off x="457200" y="4389120"/>
-            <a:ext cx="8229600" cy="320040"/>
+            <a:off x="457200" y="3840480"/>
+            <a:ext cx="8229600" cy="685800"/>
           </a:xfrm>
           <a:prstGeom prst="rect">
             <a:avLst/>
@@ -6592,10 +6592,10 @@
           <a:ln/>
         </p:spPr>
         <p:txBody>
-          <a:bodyPr wrap="square" lIns="0" tIns="0" rIns="0" bIns="0" rtlCol="0" anchor="ctr"/>
-          <a:lstStyle/>
-          <a:p>
-            <a:pPr algn="ctr" indent="0" marL="0">
+          <a:bodyPr wrap="square" lIns="0" tIns="0" rIns="0" bIns="0" rtlCol="0" anchor="t"/>
+          <a:lstStyle/>
+          <a:p>
+            <a:pPr algn="l" indent="0" marL="0">
               <a:buNone/>
             </a:pPr>
             <a:r>
@@ -6607,7 +6607,7 @@
                 <a:ea typeface="Calibri" pitchFamily="34" charset="-122"/>
                 <a:cs typeface="Calibri" pitchFamily="34" charset="-120"/>
               </a:rPr>
-              <a:t>Modo demo en http://localhost:3000/agente?demo=1: sin login y sin gastar cuota</a:t>
+              <a:t>Gemini real con el catálogo real: el pedido supera el presupuesto, replanifica, deja la alerta guardada y luego la revisa recordando lo que aprendió.</a:t>
             </a:r>
             <a:endParaRPr lang="en-US" sz="1400" dirty="0"/>
           </a:p>

</xml_diff>

<commit_message>
fix(agente): guardar listas solo si se piden, limpiar puntuación suelta y usar capturas reales en la presentación (#9)
- save_shopping_list ahora es una regla en código: si el pedido no menciona lista/guardar/armar/anotar,
  no guarda nada y le dice al modelo que ofrezca guardarla (Gemini ignoraba la instrucción del prompt).
  La escritura rechazada no cuenta como escritura ni dispara un replan.
- La respuesta ya no empieza con puntuación suelta (".He revisado…").
- Diapositiva 8 con capturas reales de /agente (Gemini y catálogo reales) en vez de las de la demo.

Co-authored-by: nikocode <nicolasestefaniad@gmail.com>
Co-authored-by: Claude Sonnet 5.5 <noreply@anthropic.com>
</commit_message>
<xml_diff>
--- a/docs/agente/Presentacion_EP2_Agente_TodoBarato.pptx
+++ b/docs/agente/Presentacion_EP2_Agente_TodoBarato.pptx
@@ -116,31 +116,31 @@
   <p:extLst>
     <p:ext uri="{521415D9-36F7-43E2-AB2F-B90AF26B5E84}">
       <p14:sectionLst xmlns:p14="http://schemas.microsoft.com/office/powerpoint/2010/main">
-        <p14:section name="Apertura" id="{e1216ebd-0070-6b56-5e65-e0fe532391e0}">
+        <p14:section name="Apertura" id="{dac7d5ba-85e2-ba81-386d-72d24eed0ed1}">
           <p14:sldIdLst>
             <p14:sldId id="256"/>
           </p14:sldIdLst>
         </p14:section>
-        <p14:section name="Diseño" id="{39f60a36-2ae4-f76a-4045-c3b28e57e01a}">
+        <p14:section name="Diseño" id="{46b5a94e-aaeb-3785-5c4b-a43d6c793877}">
           <p14:sldIdLst>
             <p14:sldId id="257"/>
             <p14:sldId id="258"/>
             <p14:sldId id="259"/>
           </p14:sldIdLst>
         </p14:section>
-        <p14:section name="Comportamiento" id="{85096e05-4263-1b5b-6bea-51bf18a99fe5}">
+        <p14:section name="Comportamiento" id="{98f8e07d-934a-1001-8a01-8d72e042b93f}">
           <p14:sldIdLst>
             <p14:sldId id="260"/>
             <p14:sldId id="261"/>
           </p14:sldIdLst>
         </p14:section>
-        <p14:section name="Demostración" id="{d252b8d0-0393-4885-1035-cf045dd2d57a}">
+        <p14:section name="Demostración" id="{7dc20ede-9775-b461-7ea4-9a971af367d1}">
           <p14:sldIdLst>
             <p14:sldId id="262"/>
             <p14:sldId id="263"/>
           </p14:sldIdLst>
         </p14:section>
-        <p14:section name="Cierre" id="{b623fd6c-9784-4d7b-bb72-b871bb97367a}">
+        <p14:section name="Cierre" id="{fff423d0-f37c-9be9-b5f1-701f3c844a32}">
           <p14:sldIdLst>
             <p14:sldId id="264"/>
             <p14:sldId id="265"/>
@@ -1254,7 +1254,7 @@
           <a:p>
             <a:r>
               <a:rPr lang="en-US" dirty="0"/>
-              <a:t>Presenta: Ariel. 45 s. Capturas de la pantalla /agente en modo demo (se abre con /agente?demo=1; sin ese parámetro la pantalla usa Gemini real). Izquierda: historia 2, el panel «Cómo pensó» muestra el plan, la búsqueda sin resultados y el cambio de estrategia. Derecha: tras simular la baja de precio, la alerta se cumple y queda registrada en «Guardado». Para mostrarla en vivo: backend en el puerto 8000, frontend con pnpm dev y abrir http://localhost:3000/agente?demo=1.</a:t>
+              <a:t>Presenta: Ariel. 45 s. Capturas reales de /agente con Gemini y el catálogo real de Supabase. Izquierda: el pedido del HP Victus ($1.336.540) supera el presupuesto de $1.000.000; en «Cómo pensó» se ve el recuadro naranja del replan y la alerta creada (marca ESCRIBE). Derecha: en una conversación nueva, «Revisa mis alertas» encuentra la alerta y, en «Memoria que usó», recuerda la preferencia por Samsung y la tarea anterior. Para mostrarlo en vivo: backend en el puerto 8000, frontend con pnpm dev e iniciar sesión en http://localhost:3000/agente. Respaldo sin Gemini ni login: /agente?demo=1.</a:t>
             </a:r>
             <a:endParaRPr lang="en-US" dirty="0"/>
           </a:p>
@@ -6399,11 +6399,11 @@
         <p:spPr>
           <a:xfrm>
             <a:off x="457200" y="1097280"/>
-            <a:ext cx="4023360" cy="2697480"/>
+            <a:ext cx="4023360" cy="2103120"/>
           </a:xfrm>
           <a:prstGeom prst="roundRect">
             <a:avLst>
-              <a:gd name="adj" fmla="val 3390"/>
+              <a:gd name="adj" fmla="val 4348"/>
             </a:avLst>
           </a:prstGeom>
           <a:solidFill>
@@ -6421,7 +6421,7 @@
       </p:sp>
       <p:pic>
         <p:nvPicPr>
-          <p:cNvPr id="5" name="Image 0" descr="Plan, herramientas y replanes en vivo">    </p:cNvPr>
+          <p:cNvPr id="5" name="Image 0" descr="Replanifica y crea la alerta">    </p:cNvPr>
           <p:cNvPicPr>
             <a:picLocks noChangeAspect="1"/>
           </p:cNvPicPr>
@@ -6436,7 +6436,7 @@
         <p:spPr>
           <a:xfrm>
             <a:off x="548640" y="1188720"/>
-            <a:ext cx="3840480" cy="2400300"/>
+            <a:ext cx="3840480" cy="1836115"/>
           </a:xfrm>
           <a:prstGeom prst="rect">
             <a:avLst/>
@@ -6451,7 +6451,7 @@
         </p:nvSpPr>
         <p:spPr>
           <a:xfrm>
-            <a:off x="457200" y="3931920"/>
+            <a:off x="457200" y="3291840"/>
             <a:ext cx="4023360" cy="365760"/>
           </a:xfrm>
           <a:prstGeom prst="rect">
@@ -6476,7 +6476,7 @@
                 <a:ea typeface="Calibri" pitchFamily="34" charset="-122"/>
                 <a:cs typeface="Calibri" pitchFamily="34" charset="-120"/>
               </a:rPr>
-              <a:t>Plan, herramientas y replanes en vivo</a:t>
+              <a:t>Replanifica y crea la alerta</a:t>
             </a:r>
             <a:endParaRPr lang="en-US" sz="1400" dirty="0"/>
           </a:p>
@@ -6491,11 +6491,11 @@
         <p:spPr>
           <a:xfrm>
             <a:off x="4663440" y="1097280"/>
-            <a:ext cx="4023360" cy="2697480"/>
+            <a:ext cx="4023360" cy="2103120"/>
           </a:xfrm>
           <a:prstGeom prst="roundRect">
             <a:avLst>
-              <a:gd name="adj" fmla="val 3390"/>
+              <a:gd name="adj" fmla="val 4348"/>
             </a:avLst>
           </a:prstGeom>
           <a:solidFill>
@@ -6513,7 +6513,7 @@
       </p:sp>
       <p:pic>
         <p:nvPicPr>
-          <p:cNvPr id="8" name="Image 1" descr="La alerta se cumple y queda guardada">    </p:cNvPr>
+          <p:cNvPr id="8" name="Image 1" descr="Revisa la alerta y usa su memoria">    </p:cNvPr>
           <p:cNvPicPr>
             <a:picLocks noChangeAspect="1"/>
           </p:cNvPicPr>
@@ -6528,7 +6528,7 @@
         <p:spPr>
           <a:xfrm>
             <a:off x="4754880" y="1188720"/>
-            <a:ext cx="3840480" cy="2400300"/>
+            <a:ext cx="3840480" cy="1836115"/>
           </a:xfrm>
           <a:prstGeom prst="rect">
             <a:avLst/>
@@ -6543,7 +6543,7 @@
         </p:nvSpPr>
         <p:spPr>
           <a:xfrm>
-            <a:off x="4663440" y="3931920"/>
+            <a:off x="4663440" y="3291840"/>
             <a:ext cx="4023360" cy="365760"/>
           </a:xfrm>
           <a:prstGeom prst="rect">
@@ -6568,7 +6568,7 @@
                 <a:ea typeface="Calibri" pitchFamily="34" charset="-122"/>
                 <a:cs typeface="Calibri" pitchFamily="34" charset="-120"/>
               </a:rPr>
-              <a:t>La alerta se cumple y queda guardada</a:t>
+              <a:t>Revisa la alerta y usa su memoria</a:t>
             </a:r>
             <a:endParaRPr lang="en-US" sz="1400" dirty="0"/>
           </a:p>
@@ -6582,8 +6582,8 @@
         </p:nvSpPr>
         <p:spPr>
           <a:xfrm>
-            <a:off x="457200" y="4389120"/>
-            <a:ext cx="8229600" cy="320040"/>
+            <a:off x="457200" y="3840480"/>
+            <a:ext cx="8229600" cy="685800"/>
           </a:xfrm>
           <a:prstGeom prst="rect">
             <a:avLst/>
@@ -6592,10 +6592,10 @@
           <a:ln/>
         </p:spPr>
         <p:txBody>
-          <a:bodyPr wrap="square" lIns="0" tIns="0" rIns="0" bIns="0" rtlCol="0" anchor="ctr"/>
-          <a:lstStyle/>
-          <a:p>
-            <a:pPr algn="ctr" indent="0" marL="0">
+          <a:bodyPr wrap="square" lIns="0" tIns="0" rIns="0" bIns="0" rtlCol="0" anchor="t"/>
+          <a:lstStyle/>
+          <a:p>
+            <a:pPr algn="l" indent="0" marL="0">
               <a:buNone/>
             </a:pPr>
             <a:r>
@@ -6607,7 +6607,7 @@
                 <a:ea typeface="Calibri" pitchFamily="34" charset="-122"/>
                 <a:cs typeface="Calibri" pitchFamily="34" charset="-120"/>
               </a:rPr>
-              <a:t>Modo demo en http://localhost:3000/agente?demo=1: sin login y sin gastar cuota</a:t>
+              <a:t>Gemini real con el catálogo real: el pedido supera el presupuesto, replanifica, deja la alerta guardada y luego la revisa recordando lo que aprendió.</a:t>
             </a:r>
             <a:endParaRPr lang="en-US" sz="1400" dirty="0"/>
           </a:p>

</xml_diff>